<commit_message>
repair metrics authorization improve pinocchio UI
</commit_message>
<xml_diff>
--- a/docs/_media/kwirth_presentation.pptx
+++ b/docs/_media/kwirth_presentation.pptx
@@ -5,7 +5,7 @@
     <p:sldMasterId id="2147483648" r:id="rId1"/>
   </p:sldMasterIdLst>
   <p:notesMasterIdLst>
-    <p:notesMasterId r:id="rId17"/>
+    <p:notesMasterId r:id="rId18"/>
   </p:notesMasterIdLst>
   <p:sldIdLst>
     <p:sldId id="256" r:id="rId2"/>
@@ -16,13 +16,14 @@
     <p:sldId id="261" r:id="rId7"/>
     <p:sldId id="262" r:id="rId8"/>
     <p:sldId id="263" r:id="rId9"/>
-    <p:sldId id="264" r:id="rId10"/>
-    <p:sldId id="265" r:id="rId11"/>
-    <p:sldId id="266" r:id="rId12"/>
-    <p:sldId id="267" r:id="rId13"/>
-    <p:sldId id="268" r:id="rId14"/>
-    <p:sldId id="269" r:id="rId15"/>
-    <p:sldId id="270" r:id="rId16"/>
+    <p:sldId id="271" r:id="rId10"/>
+    <p:sldId id="264" r:id="rId11"/>
+    <p:sldId id="265" r:id="rId12"/>
+    <p:sldId id="266" r:id="rId13"/>
+    <p:sldId id="267" r:id="rId14"/>
+    <p:sldId id="268" r:id="rId15"/>
+    <p:sldId id="269" r:id="rId16"/>
+    <p:sldId id="270" r:id="rId17"/>
   </p:sldIdLst>
   <p:sldSz cx="9144000" cy="5143500" type="screen16x9"/>
   <p:notesSz cx="5143500" cy="9144000"/>
@@ -279,6 +280,13 @@
           </p:nvPr>
         </p:nvSpPr>
         <p:spPr/>
+        <p:txBody>
+          <a:bodyPr/>
+          <a:lstStyle/>
+          <a:p>
+            <a:endParaRPr lang="es-ES"/>
+          </a:p>
+        </p:txBody>
       </p:sp>
       <p:sp>
         <p:nvSpPr>
@@ -363,6 +371,13 @@
           </p:nvPr>
         </p:nvSpPr>
         <p:spPr/>
+        <p:txBody>
+          <a:bodyPr/>
+          <a:lstStyle/>
+          <a:p>
+            <a:endParaRPr lang="es-ES"/>
+          </a:p>
+        </p:txBody>
       </p:sp>
       <p:sp>
         <p:nvSpPr>
@@ -400,7 +415,7 @@
           <a:p>
             <a:fld id="{F7021451-1387-4CA6-816F-3879F97B5CBC}" type="slidenum">
               <a:rPr lang="en-US"/>
-              <a:t>10</a:t>
+              <a:t>11</a:t>
             </a:fld>
             <a:endParaRPr lang="en-US"/>
           </a:p>
@@ -447,6 +462,13 @@
           </p:nvPr>
         </p:nvSpPr>
         <p:spPr/>
+        <p:txBody>
+          <a:bodyPr/>
+          <a:lstStyle/>
+          <a:p>
+            <a:endParaRPr lang="es-ES"/>
+          </a:p>
+        </p:txBody>
       </p:sp>
       <p:sp>
         <p:nvSpPr>
@@ -484,7 +506,7 @@
           <a:p>
             <a:fld id="{F7021451-1387-4CA6-816F-3879F97B5CBC}" type="slidenum">
               <a:rPr lang="en-US"/>
-              <a:t>11</a:t>
+              <a:t>12</a:t>
             </a:fld>
             <a:endParaRPr lang="en-US"/>
           </a:p>
@@ -531,6 +553,13 @@
           </p:nvPr>
         </p:nvSpPr>
         <p:spPr/>
+        <p:txBody>
+          <a:bodyPr/>
+          <a:lstStyle/>
+          <a:p>
+            <a:endParaRPr lang="es-ES"/>
+          </a:p>
+        </p:txBody>
       </p:sp>
       <p:sp>
         <p:nvSpPr>
@@ -568,7 +597,7 @@
           <a:p>
             <a:fld id="{F7021451-1387-4CA6-816F-3879F97B5CBC}" type="slidenum">
               <a:rPr lang="en-US"/>
-              <a:t>12</a:t>
+              <a:t>13</a:t>
             </a:fld>
             <a:endParaRPr lang="en-US"/>
           </a:p>
@@ -615,6 +644,13 @@
           </p:nvPr>
         </p:nvSpPr>
         <p:spPr/>
+        <p:txBody>
+          <a:bodyPr/>
+          <a:lstStyle/>
+          <a:p>
+            <a:endParaRPr lang="es-ES"/>
+          </a:p>
+        </p:txBody>
       </p:sp>
       <p:sp>
         <p:nvSpPr>
@@ -652,7 +688,7 @@
           <a:p>
             <a:fld id="{F7021451-1387-4CA6-816F-3879F97B5CBC}" type="slidenum">
               <a:rPr lang="en-US"/>
-              <a:t>13</a:t>
+              <a:t>14</a:t>
             </a:fld>
             <a:endParaRPr lang="en-US"/>
           </a:p>
@@ -699,6 +735,13 @@
           </p:nvPr>
         </p:nvSpPr>
         <p:spPr/>
+        <p:txBody>
+          <a:bodyPr/>
+          <a:lstStyle/>
+          <a:p>
+            <a:endParaRPr lang="es-ES"/>
+          </a:p>
+        </p:txBody>
       </p:sp>
       <p:sp>
         <p:nvSpPr>
@@ -736,7 +779,7 @@
           <a:p>
             <a:fld id="{F7021451-1387-4CA6-816F-3879F97B5CBC}" type="slidenum">
               <a:rPr lang="en-US"/>
-              <a:t>14</a:t>
+              <a:t>15</a:t>
             </a:fld>
             <a:endParaRPr lang="en-US"/>
           </a:p>
@@ -783,6 +826,13 @@
           </p:nvPr>
         </p:nvSpPr>
         <p:spPr/>
+        <p:txBody>
+          <a:bodyPr/>
+          <a:lstStyle/>
+          <a:p>
+            <a:endParaRPr lang="es-ES"/>
+          </a:p>
+        </p:txBody>
       </p:sp>
       <p:sp>
         <p:nvSpPr>
@@ -820,7 +870,7 @@
           <a:p>
             <a:fld id="{F7021451-1387-4CA6-816F-3879F97B5CBC}" type="slidenum">
               <a:rPr lang="en-US"/>
-              <a:t>15</a:t>
+              <a:t>16</a:t>
             </a:fld>
             <a:endParaRPr lang="en-US"/>
           </a:p>
@@ -867,6 +917,13 @@
           </p:nvPr>
         </p:nvSpPr>
         <p:spPr/>
+        <p:txBody>
+          <a:bodyPr/>
+          <a:lstStyle/>
+          <a:p>
+            <a:endParaRPr lang="es-ES"/>
+          </a:p>
+        </p:txBody>
       </p:sp>
       <p:sp>
         <p:nvSpPr>
@@ -951,6 +1008,13 @@
           </p:nvPr>
         </p:nvSpPr>
         <p:spPr/>
+        <p:txBody>
+          <a:bodyPr/>
+          <a:lstStyle/>
+          <a:p>
+            <a:endParaRPr lang="es-ES"/>
+          </a:p>
+        </p:txBody>
       </p:sp>
       <p:sp>
         <p:nvSpPr>
@@ -1035,6 +1099,13 @@
           </p:nvPr>
         </p:nvSpPr>
         <p:spPr/>
+        <p:txBody>
+          <a:bodyPr/>
+          <a:lstStyle/>
+          <a:p>
+            <a:endParaRPr lang="es-ES"/>
+          </a:p>
+        </p:txBody>
       </p:sp>
       <p:sp>
         <p:nvSpPr>
@@ -1119,6 +1190,13 @@
           </p:nvPr>
         </p:nvSpPr>
         <p:spPr/>
+        <p:txBody>
+          <a:bodyPr/>
+          <a:lstStyle/>
+          <a:p>
+            <a:endParaRPr lang="es-ES"/>
+          </a:p>
+        </p:txBody>
       </p:sp>
       <p:sp>
         <p:nvSpPr>
@@ -1203,6 +1281,13 @@
           </p:nvPr>
         </p:nvSpPr>
         <p:spPr/>
+        <p:txBody>
+          <a:bodyPr/>
+          <a:lstStyle/>
+          <a:p>
+            <a:endParaRPr lang="es-ES"/>
+          </a:p>
+        </p:txBody>
       </p:sp>
       <p:sp>
         <p:nvSpPr>
@@ -1287,6 +1372,13 @@
           </p:nvPr>
         </p:nvSpPr>
         <p:spPr/>
+        <p:txBody>
+          <a:bodyPr/>
+          <a:lstStyle/>
+          <a:p>
+            <a:endParaRPr lang="es-ES"/>
+          </a:p>
+        </p:txBody>
       </p:sp>
       <p:sp>
         <p:nvSpPr>
@@ -1371,6 +1463,13 @@
           </p:nvPr>
         </p:nvSpPr>
         <p:spPr/>
+        <p:txBody>
+          <a:bodyPr/>
+          <a:lstStyle/>
+          <a:p>
+            <a:endParaRPr lang="es-ES"/>
+          </a:p>
+        </p:txBody>
       </p:sp>
       <p:sp>
         <p:nvSpPr>
@@ -1455,6 +1554,13 @@
           </p:nvPr>
         </p:nvSpPr>
         <p:spPr/>
+        <p:txBody>
+          <a:bodyPr/>
+          <a:lstStyle/>
+          <a:p>
+            <a:endParaRPr lang="es-ES"/>
+          </a:p>
+        </p:txBody>
       </p:sp>
       <p:sp>
         <p:nvSpPr>
@@ -1492,7 +1598,7 @@
           <a:p>
             <a:fld id="{F7021451-1387-4CA6-816F-3879F97B5CBC}" type="slidenum">
               <a:rPr lang="en-US"/>
-              <a:t>9</a:t>
+              <a:t>10</a:t>
             </a:fld>
             <a:endParaRPr lang="en-US"/>
           </a:p>
@@ -2288,7 +2394,7 @@
             </a:stretch>
           </p:blipFill>
           <p:spPr>
-            <a:xfrm>
+            <a:xfrm rot="10800000">
               <a:off x="6418389" y="464739"/>
               <a:ext cx="474789" cy="762162"/>
             </a:xfrm>
@@ -2338,7 +2444,7 @@
               </a:stretch>
             </p:blipFill>
             <p:spPr>
-              <a:xfrm>
+              <a:xfrm rot="10800000">
                 <a:off x="6893178" y="457200"/>
                 <a:ext cx="474789" cy="762162"/>
               </a:xfrm>
@@ -3472,8 +3578,8 @@
               </a:stretch>
             </p:blipFill>
             <p:spPr>
-              <a:xfrm rot="10800000">
-                <a:off x="5943600" y="1219119"/>
+              <a:xfrm>
+                <a:off x="5943600" y="1219120"/>
                 <a:ext cx="474789" cy="762162"/>
               </a:xfrm>
               <a:prstGeom prst="rect">
@@ -3727,6 +3833,497 @@
 
 <file path=ppt/slides/slide10.xml><?xml version="1.0" encoding="utf-8"?>
 <p:sld xmlns:a="http://schemas.openxmlformats.org/drawingml/2006/main" xmlns:r="http://schemas.openxmlformats.org/officeDocument/2006/relationships" xmlns:p="http://schemas.openxmlformats.org/presentationml/2006/main">
+  <p:cSld name="Slide 9">
+    <p:bg>
+      <p:bgPr>
+        <a:solidFill>
+          <a:srgbClr val="0F172A"/>
+        </a:solidFill>
+        <a:effectLst/>
+      </p:bgPr>
+    </p:bg>
+    <p:spTree>
+      <p:nvGrpSpPr>
+        <p:cNvPr id="1" name=""/>
+        <p:cNvGrpSpPr/>
+        <p:nvPr/>
+      </p:nvGrpSpPr>
+      <p:grpSpPr>
+        <a:xfrm>
+          <a:off x="0" y="0"/>
+          <a:ext cx="0" cy="0"/>
+          <a:chOff x="0" y="0"/>
+          <a:chExt cx="0" cy="0"/>
+        </a:xfrm>
+      </p:grpSpPr>
+      <p:sp>
+        <p:nvSpPr>
+          <p:cNvPr id="2" name="Shape 0"/>
+          <p:cNvSpPr/>
+          <p:nvPr/>
+        </p:nvSpPr>
+        <p:spPr>
+          <a:xfrm>
+            <a:off x="0" y="0"/>
+            <a:ext cx="9144000" cy="5143500"/>
+          </a:xfrm>
+          <a:prstGeom prst="rect">
+            <a:avLst/>
+          </a:prstGeom>
+          <a:solidFill>
+            <a:srgbClr val="0C1829"/>
+          </a:solidFill>
+          <a:ln/>
+        </p:spPr>
+        <p:txBody>
+          <a:bodyPr/>
+          <a:lstStyle/>
+          <a:p>
+            <a:endParaRPr lang="es-ES"/>
+          </a:p>
+        </p:txBody>
+      </p:sp>
+      <p:sp>
+        <p:nvSpPr>
+          <p:cNvPr id="3" name="Text 1"/>
+          <p:cNvSpPr/>
+          <p:nvPr/>
+        </p:nvSpPr>
+        <p:spPr>
+          <a:xfrm>
+            <a:off x="457200" y="385354"/>
+            <a:ext cx="8229600" cy="914400"/>
+          </a:xfrm>
+          <a:prstGeom prst="rect">
+            <a:avLst/>
+          </a:prstGeom>
+          <a:noFill/>
+          <a:ln/>
+        </p:spPr>
+        <p:txBody>
+          <a:bodyPr wrap="square" lIns="0" tIns="0" rIns="0" bIns="0" rtlCol="0" anchor="ctr"/>
+          <a:lstStyle/>
+          <a:p>
+            <a:pPr marL="0" indent="0" algn="ctr">
+              <a:buNone/>
+            </a:pPr>
+            <a:r>
+              <a:rPr lang="en-US" sz="7200" b="1" kern="0" spc="800" dirty="0">
+                <a:solidFill>
+                  <a:srgbClr val="38BDF8"/>
+                </a:solidFill>
+                <a:latin typeface="Consolas" pitchFamily="34" charset="0"/>
+                <a:ea typeface="Consolas" pitchFamily="34" charset="-122"/>
+                <a:cs typeface="Consolas" pitchFamily="34" charset="-120"/>
+              </a:rPr>
+              <a:t>[ DEMO ]</a:t>
+            </a:r>
+            <a:endParaRPr lang="en-US" sz="7200" dirty="0"/>
+          </a:p>
+        </p:txBody>
+      </p:sp>
+      <p:sp>
+        <p:nvSpPr>
+          <p:cNvPr id="4" name="Text 2"/>
+          <p:cNvSpPr/>
+          <p:nvPr/>
+        </p:nvSpPr>
+        <p:spPr>
+          <a:xfrm>
+            <a:off x="457200" y="1391194"/>
+            <a:ext cx="8229600" cy="502920"/>
+          </a:xfrm>
+          <a:prstGeom prst="rect">
+            <a:avLst/>
+          </a:prstGeom>
+          <a:noFill/>
+          <a:ln/>
+        </p:spPr>
+        <p:txBody>
+          <a:bodyPr wrap="square" lIns="0" tIns="0" rIns="0" bIns="0" rtlCol="0" anchor="ctr"/>
+          <a:lstStyle/>
+          <a:p>
+            <a:pPr marL="0" indent="0" algn="ctr">
+              <a:buNone/>
+            </a:pPr>
+            <a:r>
+              <a:rPr lang="en-US" sz="2800" dirty="0">
+                <a:solidFill>
+                  <a:srgbClr val="FFFFFF"/>
+                </a:solidFill>
+                <a:latin typeface="Trebuchet MS" pitchFamily="34" charset="0"/>
+                <a:ea typeface="Trebuchet MS" pitchFamily="34" charset="-122"/>
+                <a:cs typeface="Trebuchet MS" pitchFamily="34" charset="-120"/>
+              </a:rPr>
+              <a:t>Let’s see Kwirth in action 🚀</a:t>
+            </a:r>
+            <a:endParaRPr lang="en-US" sz="2800" dirty="0"/>
+          </a:p>
+        </p:txBody>
+      </p:sp>
+      <p:sp>
+        <p:nvSpPr>
+          <p:cNvPr id="5" name="Shape 3"/>
+          <p:cNvSpPr/>
+          <p:nvPr/>
+        </p:nvSpPr>
+        <p:spPr>
+          <a:xfrm>
+            <a:off x="1371600" y="2076994"/>
+            <a:ext cx="6400800" cy="438912"/>
+          </a:xfrm>
+          <a:prstGeom prst="rect">
+            <a:avLst/>
+          </a:prstGeom>
+          <a:solidFill>
+            <a:srgbClr val="1E293B"/>
+          </a:solidFill>
+          <a:ln/>
+        </p:spPr>
+        <p:txBody>
+          <a:bodyPr/>
+          <a:lstStyle/>
+          <a:p>
+            <a:endParaRPr lang="es-ES"/>
+          </a:p>
+        </p:txBody>
+      </p:sp>
+      <p:sp>
+        <p:nvSpPr>
+          <p:cNvPr id="6" name="Text 4"/>
+          <p:cNvSpPr/>
+          <p:nvPr/>
+        </p:nvSpPr>
+        <p:spPr>
+          <a:xfrm>
+            <a:off x="1554480" y="2076994"/>
+            <a:ext cx="6035040" cy="438912"/>
+          </a:xfrm>
+          <a:prstGeom prst="rect">
+            <a:avLst/>
+          </a:prstGeom>
+          <a:noFill/>
+          <a:ln/>
+        </p:spPr>
+        <p:txBody>
+          <a:bodyPr wrap="square" lIns="0" tIns="0" rIns="0" bIns="0" rtlCol="0" anchor="ctr"/>
+          <a:lstStyle/>
+          <a:p>
+            <a:pPr marL="0" indent="0">
+              <a:buNone/>
+            </a:pPr>
+            <a:r>
+              <a:rPr lang="en-US" sz="1500" dirty="0">
+                <a:solidFill>
+                  <a:srgbClr val="E2E8F0"/>
+                </a:solidFill>
+                <a:latin typeface="Calibri" pitchFamily="34" charset="0"/>
+                <a:ea typeface="Calibri" pitchFamily="34" charset="-122"/>
+                <a:cs typeface="Calibri" pitchFamily="34" charset="-120"/>
+              </a:rPr>
+              <a:t>1.  Real time log streaming</a:t>
+            </a:r>
+            <a:endParaRPr lang="en-US" sz="1500" dirty="0"/>
+          </a:p>
+        </p:txBody>
+      </p:sp>
+      <p:sp>
+        <p:nvSpPr>
+          <p:cNvPr id="7" name="Shape 5"/>
+          <p:cNvSpPr/>
+          <p:nvPr/>
+        </p:nvSpPr>
+        <p:spPr>
+          <a:xfrm>
+            <a:off x="1371600" y="2625634"/>
+            <a:ext cx="6400800" cy="438912"/>
+          </a:xfrm>
+          <a:prstGeom prst="rect">
+            <a:avLst/>
+          </a:prstGeom>
+          <a:solidFill>
+            <a:srgbClr val="1E293B"/>
+          </a:solidFill>
+          <a:ln/>
+        </p:spPr>
+        <p:txBody>
+          <a:bodyPr/>
+          <a:lstStyle/>
+          <a:p>
+            <a:endParaRPr lang="es-ES"/>
+          </a:p>
+        </p:txBody>
+      </p:sp>
+      <p:sp>
+        <p:nvSpPr>
+          <p:cNvPr id="8" name="Text 6"/>
+          <p:cNvSpPr/>
+          <p:nvPr/>
+        </p:nvSpPr>
+        <p:spPr>
+          <a:xfrm>
+            <a:off x="1554480" y="2625634"/>
+            <a:ext cx="6035040" cy="438912"/>
+          </a:xfrm>
+          <a:prstGeom prst="rect">
+            <a:avLst/>
+          </a:prstGeom>
+          <a:noFill/>
+          <a:ln/>
+        </p:spPr>
+        <p:txBody>
+          <a:bodyPr wrap="square" lIns="0" tIns="0" rIns="0" bIns="0" rtlCol="0" anchor="ctr"/>
+          <a:lstStyle/>
+          <a:p>
+            <a:pPr marL="0" indent="0">
+              <a:buNone/>
+            </a:pPr>
+            <a:r>
+              <a:rPr lang="en-US" sz="1500" dirty="0">
+                <a:solidFill>
+                  <a:srgbClr val="E2E8F0"/>
+                </a:solidFill>
+                <a:latin typeface="Calibri" pitchFamily="34" charset="0"/>
+                <a:ea typeface="Calibri" pitchFamily="34" charset="-122"/>
+                <a:cs typeface="Calibri" pitchFamily="34" charset="-120"/>
+              </a:rPr>
+              <a:t>2.  Namespaces &amp; pod metrics</a:t>
+            </a:r>
+            <a:endParaRPr lang="en-US" sz="1500" dirty="0"/>
+          </a:p>
+        </p:txBody>
+      </p:sp>
+      <p:sp>
+        <p:nvSpPr>
+          <p:cNvPr id="9" name="Shape 7"/>
+          <p:cNvSpPr/>
+          <p:nvPr/>
+        </p:nvSpPr>
+        <p:spPr>
+          <a:xfrm>
+            <a:off x="1371600" y="3722914"/>
+            <a:ext cx="6400800" cy="438912"/>
+          </a:xfrm>
+          <a:prstGeom prst="rect">
+            <a:avLst/>
+          </a:prstGeom>
+          <a:solidFill>
+            <a:srgbClr val="1E293B"/>
+          </a:solidFill>
+          <a:ln/>
+        </p:spPr>
+        <p:txBody>
+          <a:bodyPr/>
+          <a:lstStyle/>
+          <a:p>
+            <a:endParaRPr lang="es-ES"/>
+          </a:p>
+        </p:txBody>
+      </p:sp>
+      <p:sp>
+        <p:nvSpPr>
+          <p:cNvPr id="10" name="Text 8"/>
+          <p:cNvSpPr/>
+          <p:nvPr/>
+        </p:nvSpPr>
+        <p:spPr>
+          <a:xfrm>
+            <a:off x="1554480" y="3722914"/>
+            <a:ext cx="6035040" cy="438912"/>
+          </a:xfrm>
+          <a:prstGeom prst="rect">
+            <a:avLst/>
+          </a:prstGeom>
+          <a:noFill/>
+          <a:ln/>
+        </p:spPr>
+        <p:txBody>
+          <a:bodyPr wrap="square" lIns="0" tIns="0" rIns="0" bIns="0" rtlCol="0" anchor="ctr"/>
+          <a:lstStyle/>
+          <a:p>
+            <a:pPr marL="0" indent="0">
+              <a:buNone/>
+            </a:pPr>
+            <a:r>
+              <a:rPr lang="en-US" sz="1500" dirty="0">
+                <a:solidFill>
+                  <a:srgbClr val="E2E8F0"/>
+                </a:solidFill>
+                <a:latin typeface="Calibri" pitchFamily="34" charset="0"/>
+                <a:ea typeface="Calibri" pitchFamily="34" charset="-122"/>
+                <a:cs typeface="Calibri" pitchFamily="34" charset="-120"/>
+              </a:rPr>
+              <a:t>4. Magnify channel — cluster management</a:t>
+            </a:r>
+            <a:endParaRPr lang="en-US" sz="1500" dirty="0"/>
+          </a:p>
+        </p:txBody>
+      </p:sp>
+      <p:sp>
+        <p:nvSpPr>
+          <p:cNvPr id="11" name="Shape 9"/>
+          <p:cNvSpPr/>
+          <p:nvPr/>
+        </p:nvSpPr>
+        <p:spPr>
+          <a:xfrm>
+            <a:off x="1371600" y="4271554"/>
+            <a:ext cx="6400800" cy="438912"/>
+          </a:xfrm>
+          <a:prstGeom prst="rect">
+            <a:avLst/>
+          </a:prstGeom>
+          <a:solidFill>
+            <a:srgbClr val="1E293B"/>
+          </a:solidFill>
+          <a:ln/>
+        </p:spPr>
+        <p:txBody>
+          <a:bodyPr/>
+          <a:lstStyle/>
+          <a:p>
+            <a:endParaRPr lang="es-ES"/>
+          </a:p>
+        </p:txBody>
+      </p:sp>
+      <p:sp>
+        <p:nvSpPr>
+          <p:cNvPr id="12" name="Text 10"/>
+          <p:cNvSpPr/>
+          <p:nvPr/>
+        </p:nvSpPr>
+        <p:spPr>
+          <a:xfrm>
+            <a:off x="1554480" y="4271554"/>
+            <a:ext cx="6035040" cy="438912"/>
+          </a:xfrm>
+          <a:prstGeom prst="rect">
+            <a:avLst/>
+          </a:prstGeom>
+          <a:noFill/>
+          <a:ln/>
+        </p:spPr>
+        <p:txBody>
+          <a:bodyPr wrap="square" lIns="0" tIns="0" rIns="0" bIns="0" rtlCol="0" anchor="ctr"/>
+          <a:lstStyle/>
+          <a:p>
+            <a:pPr marL="0" indent="0">
+              <a:buNone/>
+            </a:pPr>
+            <a:r>
+              <a:rPr lang="en-US" sz="1500" dirty="0">
+                <a:solidFill>
+                  <a:srgbClr val="E2E8F0"/>
+                </a:solidFill>
+                <a:latin typeface="Calibri" pitchFamily="34" charset="0"/>
+                <a:ea typeface="Calibri" pitchFamily="34" charset="-122"/>
+                <a:cs typeface="Calibri" pitchFamily="34" charset="-120"/>
+              </a:rPr>
+              <a:t>5.  Pinocchio — ask your LLM about your cluster</a:t>
+            </a:r>
+            <a:endParaRPr lang="en-US" sz="1500" dirty="0"/>
+          </a:p>
+        </p:txBody>
+      </p:sp>
+      <p:sp>
+        <p:nvSpPr>
+          <p:cNvPr id="13" name="Shape 7">
+            <a:extLst>
+              <a:ext uri="{FF2B5EF4-FFF2-40B4-BE49-F238E27FC236}">
+                <a16:creationId xmlns:a16="http://schemas.microsoft.com/office/drawing/2014/main" id="{9F36C51D-57EA-5028-932C-1E0CC8A00790}"/>
+              </a:ext>
+            </a:extLst>
+          </p:cNvPr>
+          <p:cNvSpPr/>
+          <p:nvPr/>
+        </p:nvSpPr>
+        <p:spPr>
+          <a:xfrm>
+            <a:off x="1371600" y="3174274"/>
+            <a:ext cx="6400800" cy="438912"/>
+          </a:xfrm>
+          <a:prstGeom prst="rect">
+            <a:avLst/>
+          </a:prstGeom>
+          <a:solidFill>
+            <a:srgbClr val="1E293B"/>
+          </a:solidFill>
+          <a:ln/>
+        </p:spPr>
+        <p:txBody>
+          <a:bodyPr/>
+          <a:lstStyle/>
+          <a:p>
+            <a:endParaRPr lang="es-ES"/>
+          </a:p>
+        </p:txBody>
+      </p:sp>
+      <p:sp>
+        <p:nvSpPr>
+          <p:cNvPr id="14" name="Text 8">
+            <a:extLst>
+              <a:ext uri="{FF2B5EF4-FFF2-40B4-BE49-F238E27FC236}">
+                <a16:creationId xmlns:a16="http://schemas.microsoft.com/office/drawing/2014/main" id="{4544036D-6EFA-D449-8DD3-52C4A0218430}"/>
+              </a:ext>
+            </a:extLst>
+          </p:cNvPr>
+          <p:cNvSpPr/>
+          <p:nvPr/>
+        </p:nvSpPr>
+        <p:spPr>
+          <a:xfrm>
+            <a:off x="1554480" y="3174274"/>
+            <a:ext cx="6035040" cy="438912"/>
+          </a:xfrm>
+          <a:prstGeom prst="rect">
+            <a:avLst/>
+          </a:prstGeom>
+          <a:noFill/>
+          <a:ln/>
+        </p:spPr>
+        <p:txBody>
+          <a:bodyPr wrap="square" lIns="0" tIns="0" rIns="0" bIns="0" rtlCol="0" anchor="ctr"/>
+          <a:lstStyle/>
+          <a:p>
+            <a:pPr marL="0" indent="0">
+              <a:buNone/>
+            </a:pPr>
+            <a:r>
+              <a:rPr lang="en-US" sz="1500" dirty="0">
+                <a:solidFill>
+                  <a:srgbClr val="E2E8F0"/>
+                </a:solidFill>
+                <a:latin typeface="Calibri" pitchFamily="34" charset="0"/>
+                <a:ea typeface="Calibri" pitchFamily="34" charset="-122"/>
+                <a:cs typeface="Calibri" pitchFamily="34" charset="-120"/>
+              </a:rPr>
+              <a:t>3.  Mor fun stuff with Fileman &amp; </a:t>
+            </a:r>
+            <a:r>
+              <a:rPr lang="en-US" sz="1500" dirty="0" err="1">
+                <a:solidFill>
+                  <a:srgbClr val="E2E8F0"/>
+                </a:solidFill>
+                <a:latin typeface="Calibri" pitchFamily="34" charset="0"/>
+                <a:ea typeface="Calibri" pitchFamily="34" charset="-122"/>
+                <a:cs typeface="Calibri" pitchFamily="34" charset="-120"/>
+              </a:rPr>
+              <a:t>Trivy</a:t>
+            </a:r>
+            <a:endParaRPr lang="en-US" sz="1500" dirty="0"/>
+          </a:p>
+        </p:txBody>
+      </p:sp>
+    </p:spTree>
+  </p:cSld>
+  <p:clrMapOvr>
+    <a:masterClrMapping/>
+  </p:clrMapOvr>
+</p:sld>
+</file>
+
+<file path=ppt/slides/slide11.xml><?xml version="1.0" encoding="utf-8"?>
+<p:sld xmlns:a="http://schemas.openxmlformats.org/drawingml/2006/main" xmlns:r="http://schemas.openxmlformats.org/officeDocument/2006/relationships" xmlns:p="http://schemas.openxmlformats.org/presentationml/2006/main">
   <p:cSld name="Slide 10">
     <p:bg>
       <p:bgPr>
@@ -4831,7 +5428,7 @@
 </p:sld>
 </file>
 
-<file path=ppt/slides/slide11.xml><?xml version="1.0" encoding="utf-8"?>
+<file path=ppt/slides/slide12.xml><?xml version="1.0" encoding="utf-8"?>
 <p:sld xmlns:a="http://schemas.openxmlformats.org/drawingml/2006/main" xmlns:r="http://schemas.openxmlformats.org/officeDocument/2006/relationships" xmlns:p="http://schemas.openxmlformats.org/presentationml/2006/main">
   <p:cSld name="Slide 11">
     <p:bg>
@@ -4920,7 +5517,7 @@
               <a:buNone/>
             </a:pPr>
             <a:r>
-              <a:rPr lang="en-US" sz="1500" i="1" dirty="0" err="1">
+              <a:rPr lang="en-US" sz="1500" i="1" dirty="0">
                 <a:solidFill>
                   <a:srgbClr val="94A3B8"/>
                 </a:solidFill>
@@ -4928,18 +5525,7 @@
                 <a:ea typeface="Calibri" pitchFamily="34" charset="-122"/>
                 <a:cs typeface="Calibri" pitchFamily="34" charset="-120"/>
               </a:rPr>
-              <a:t>Kwirth</a:t>
-            </a:r>
-            <a:r>
-              <a:rPr lang="en-US" sz="1500" i="1" dirty="0">
-                <a:solidFill>
-                  <a:srgbClr val="94A3B8"/>
-                </a:solidFill>
-                <a:latin typeface="Calibri" pitchFamily="34" charset="0"/>
-                <a:ea typeface="Calibri" pitchFamily="34" charset="-122"/>
-                <a:cs typeface="Calibri" pitchFamily="34" charset="-120"/>
-              </a:rPr>
-              <a:t> has been designed fer receiving everyone’s help, adding the value that comes from each one’s effort</a:t>
+              <a:t>Kwirth has been designed fer receiving everyone’s help, adding the value that comes from each one’s effort</a:t>
             </a:r>
             <a:endParaRPr lang="en-US" sz="1500" dirty="0"/>
           </a:p>
@@ -6017,7 +6603,7 @@
 </p:sld>
 </file>
 
-<file path=ppt/slides/slide12.xml><?xml version="1.0" encoding="utf-8"?>
+<file path=ppt/slides/slide13.xml><?xml version="1.0" encoding="utf-8"?>
 <p:sld xmlns:a="http://schemas.openxmlformats.org/drawingml/2006/main" xmlns:r="http://schemas.openxmlformats.org/officeDocument/2006/relationships" xmlns:p="http://schemas.openxmlformats.org/presentationml/2006/main">
   <p:cSld name="Slide 12">
     <p:bg>
@@ -6877,7 +7463,7 @@
 </p:sld>
 </file>
 
-<file path=ppt/slides/slide13.xml><?xml version="1.0" encoding="utf-8"?>
+<file path=ppt/slides/slide14.xml><?xml version="1.0" encoding="utf-8"?>
 <p:sld xmlns:a="http://schemas.openxmlformats.org/drawingml/2006/main" xmlns:r="http://schemas.openxmlformats.org/officeDocument/2006/relationships" xmlns:p="http://schemas.openxmlformats.org/presentationml/2006/main">
   <p:cSld name="Slide 13">
     <p:bg>
@@ -7176,29 +7762,7 @@
                 <a:ea typeface="Calibri" pitchFamily="34" charset="-122"/>
                 <a:cs typeface="Calibri" pitchFamily="34" charset="-120"/>
               </a:rPr>
-              <a:t>Working with </a:t>
-            </a:r>
-            <a:r>
-              <a:rPr lang="en-US" sz="1200" dirty="0" err="1">
-                <a:solidFill>
-                  <a:srgbClr val="94A3B8"/>
-                </a:solidFill>
-                <a:latin typeface="Calibri" pitchFamily="34" charset="0"/>
-                <a:ea typeface="Calibri" pitchFamily="34" charset="-122"/>
-                <a:cs typeface="Calibri" pitchFamily="34" charset="-120"/>
-              </a:rPr>
-              <a:t>Kwirth</a:t>
-            </a:r>
-            <a:r>
-              <a:rPr lang="en-US" sz="1200" dirty="0">
-                <a:solidFill>
-                  <a:srgbClr val="94A3B8"/>
-                </a:solidFill>
-                <a:latin typeface="Calibri" pitchFamily="34" charset="0"/>
-                <a:ea typeface="Calibri" pitchFamily="34" charset="-122"/>
-                <a:cs typeface="Calibri" pitchFamily="34" charset="-120"/>
-              </a:rPr>
-              <a:t> will lead you to learn a lot of Kubernetes.</a:t>
+              <a:t>Working with Kwirth will lead you to learn a lot of Kubernetes.</a:t>
             </a:r>
             <a:endParaRPr lang="en-US" sz="1200" dirty="0"/>
           </a:p>
@@ -7711,7 +8275,7 @@
 </p:sld>
 </file>
 
-<file path=ppt/slides/slide14.xml><?xml version="1.0" encoding="utf-8"?>
+<file path=ppt/slides/slide15.xml><?xml version="1.0" encoding="utf-8"?>
 <p:sld xmlns:a="http://schemas.openxmlformats.org/drawingml/2006/main" xmlns:r="http://schemas.openxmlformats.org/officeDocument/2006/relationships" xmlns:p="http://schemas.openxmlformats.org/presentationml/2006/main">
   <p:cSld name="Slide 14">
     <p:bg>
@@ -8213,7 +8777,18 @@
                 <a:ea typeface="Consolas" pitchFamily="34" charset="-122"/>
                 <a:cs typeface="Consolas" pitchFamily="34" charset="-120"/>
               </a:rPr>
-              <a:t>kubectl apply -f ...kwirth.yaml</a:t>
+              <a:t>kubectl apply -f ...</a:t>
+            </a:r>
+            <a:r>
+              <a:rPr lang="en-US" sz="1400" dirty="0" err="1">
+                <a:solidFill>
+                  <a:srgbClr val="38BDF8"/>
+                </a:solidFill>
+                <a:latin typeface="Consolas" pitchFamily="34" charset="0"/>
+                <a:ea typeface="Consolas" pitchFamily="34" charset="-122"/>
+                <a:cs typeface="Consolas" pitchFamily="34" charset="-120"/>
+              </a:rPr>
+              <a:t>kwirth.yaml</a:t>
             </a:r>
             <a:endParaRPr lang="en-US" sz="1400" dirty="0"/>
           </a:p>
@@ -8252,29 +8827,7 @@
                 <a:ea typeface="Calibri" pitchFamily="34" charset="-122"/>
                 <a:cs typeface="Calibri" pitchFamily="34" charset="-120"/>
               </a:rPr>
-              <a:t>Join — </a:t>
-            </a:r>
-            <a:r>
-              <a:rPr lang="en-US" sz="1800" b="1" dirty="0" err="1">
-                <a:solidFill>
-                  <a:srgbClr val="4ADE80"/>
-                </a:solidFill>
-                <a:latin typeface="Calibri" pitchFamily="34" charset="0"/>
-                <a:ea typeface="Calibri" pitchFamily="34" charset="-122"/>
-                <a:cs typeface="Calibri" pitchFamily="34" charset="-120"/>
-              </a:rPr>
-              <a:t>Kwirth</a:t>
-            </a:r>
-            <a:r>
-              <a:rPr lang="en-US" sz="1800" b="1" dirty="0">
-                <a:solidFill>
-                  <a:srgbClr val="4ADE80"/>
-                </a:solidFill>
-                <a:latin typeface="Calibri" pitchFamily="34" charset="0"/>
-                <a:ea typeface="Calibri" pitchFamily="34" charset="-122"/>
-                <a:cs typeface="Calibri" pitchFamily="34" charset="-120"/>
-              </a:rPr>
-              <a:t> will be build by a strong community! 🙌</a:t>
+              <a:t>Join — Kwirth will be build by a strong community! 🙌</a:t>
             </a:r>
             <a:endParaRPr lang="en-US" sz="1800" dirty="0"/>
           </a:p>
@@ -8288,7 +8841,7 @@
 </p:sld>
 </file>
 
-<file path=ppt/slides/slide15.xml><?xml version="1.0" encoding="utf-8"?>
+<file path=ppt/slides/slide16.xml><?xml version="1.0" encoding="utf-8"?>
 <p:sld xmlns:a="http://schemas.openxmlformats.org/drawingml/2006/main" xmlns:r="http://schemas.openxmlformats.org/officeDocument/2006/relationships" xmlns:p="http://schemas.openxmlformats.org/presentationml/2006/main">
   <p:cSld name="Slide 15">
     <p:bg>
@@ -9741,29 +10294,7 @@
                 <a:ea typeface="Trebuchet MS" pitchFamily="34" charset="-122"/>
                 <a:cs typeface="Trebuchet MS" pitchFamily="34" charset="-120"/>
               </a:rPr>
-              <a:t>What is </a:t>
-            </a:r>
-            <a:r>
-              <a:rPr lang="en-US" sz="3600" b="1" dirty="0" err="1">
-                <a:solidFill>
-                  <a:srgbClr val="FFFFFF"/>
-                </a:solidFill>
-                <a:latin typeface="Trebuchet MS" pitchFamily="34" charset="0"/>
-                <a:ea typeface="Trebuchet MS" pitchFamily="34" charset="-122"/>
-                <a:cs typeface="Trebuchet MS" pitchFamily="34" charset="-120"/>
-              </a:rPr>
-              <a:t>Kwirth</a:t>
-            </a:r>
-            <a:r>
-              <a:rPr lang="en-US" sz="3600" b="1" dirty="0">
-                <a:solidFill>
-                  <a:srgbClr val="FFFFFF"/>
-                </a:solidFill>
-                <a:latin typeface="Trebuchet MS" pitchFamily="34" charset="0"/>
-                <a:ea typeface="Trebuchet MS" pitchFamily="34" charset="-122"/>
-                <a:cs typeface="Trebuchet MS" pitchFamily="34" charset="-120"/>
-              </a:rPr>
-              <a:t>?</a:t>
+              <a:t>What is Kwirth?</a:t>
             </a:r>
             <a:endParaRPr lang="en-US" sz="3600" dirty="0"/>
           </a:p>
@@ -10426,7 +10957,29 @@
                 <a:ea typeface="Consolas" pitchFamily="34" charset="-122"/>
                 <a:cs typeface="Consolas" pitchFamily="34" charset="-120"/>
               </a:rPr>
-              <a:t>kubectl apply -f https://...kwirth.yaml   ← that’s all</a:t>
+              <a:t>kubectl apply -f https://...</a:t>
+            </a:r>
+            <a:r>
+              <a:rPr lang="en-US" sz="1200" dirty="0" err="1">
+                <a:solidFill>
+                  <a:srgbClr val="4ADE80"/>
+                </a:solidFill>
+                <a:latin typeface="Consolas" pitchFamily="34" charset="0"/>
+                <a:ea typeface="Consolas" pitchFamily="34" charset="-122"/>
+                <a:cs typeface="Consolas" pitchFamily="34" charset="-120"/>
+              </a:rPr>
+              <a:t>kwirth.yaml</a:t>
+            </a:r>
+            <a:r>
+              <a:rPr lang="en-US" sz="1200" dirty="0">
+                <a:solidFill>
+                  <a:srgbClr val="4ADE80"/>
+                </a:solidFill>
+                <a:latin typeface="Consolas" pitchFamily="34" charset="0"/>
+                <a:ea typeface="Consolas" pitchFamily="34" charset="-122"/>
+                <a:cs typeface="Consolas" pitchFamily="34" charset="-120"/>
+              </a:rPr>
+              <a:t>   ← that’s all</a:t>
             </a:r>
             <a:endParaRPr lang="en-US" sz="1200" dirty="0"/>
           </a:p>
@@ -10830,29 +11383,7 @@
                 <a:ea typeface="Calibri" pitchFamily="34" charset="-122"/>
                 <a:cs typeface="Calibri" pitchFamily="34" charset="-120"/>
               </a:rPr>
-              <a:t>Just as he used Ben-Day dots to create art from comics, </a:t>
-            </a:r>
-            <a:r>
-              <a:rPr lang="en-US" sz="1300" dirty="0" err="1">
-                <a:solidFill>
-                  <a:srgbClr val="334155"/>
-                </a:solidFill>
-                <a:latin typeface="Calibri" pitchFamily="34" charset="0"/>
-                <a:ea typeface="Calibri" pitchFamily="34" charset="-122"/>
-                <a:cs typeface="Calibri" pitchFamily="34" charset="-120"/>
-              </a:rPr>
-              <a:t>Kwirth</a:t>
-            </a:r>
-            <a:r>
-              <a:rPr lang="en-US" sz="1300" dirty="0">
-                <a:solidFill>
-                  <a:srgbClr val="334155"/>
-                </a:solidFill>
-                <a:latin typeface="Calibri" pitchFamily="34" charset="0"/>
-                <a:ea typeface="Calibri" pitchFamily="34" charset="-122"/>
-                <a:cs typeface="Calibri" pitchFamily="34" charset="-120"/>
-              </a:rPr>
-              <a:t> takes the cluster's "dots" (logs, metrics, events) and magnifies them into something clear and visual.</a:t>
+              <a:t>Just as he used Ben-Day dots to create art from comics, Kwirth takes the cluster's "dots" (logs, metrics, events) and magnifies them into something clear and visual.</a:t>
             </a:r>
           </a:p>
           <a:p>
@@ -14471,29 +15002,7 @@
                 <a:ea typeface="Trebuchet MS" pitchFamily="34" charset="-122"/>
                 <a:cs typeface="Trebuchet MS" pitchFamily="34" charset="-120"/>
               </a:rPr>
-              <a:t>How to deploy </a:t>
-            </a:r>
-            <a:r>
-              <a:rPr lang="en-US" sz="3600" b="1" dirty="0" err="1">
-                <a:solidFill>
-                  <a:srgbClr val="0F172A"/>
-                </a:solidFill>
-                <a:latin typeface="Trebuchet MS" pitchFamily="34" charset="0"/>
-                <a:ea typeface="Trebuchet MS" pitchFamily="34" charset="-122"/>
-                <a:cs typeface="Trebuchet MS" pitchFamily="34" charset="-120"/>
-              </a:rPr>
-              <a:t>Kwirth</a:t>
-            </a:r>
-            <a:r>
-              <a:rPr lang="en-US" sz="3600" b="1" dirty="0">
-                <a:solidFill>
-                  <a:srgbClr val="0F172A"/>
-                </a:solidFill>
-                <a:latin typeface="Trebuchet MS" pitchFamily="34" charset="0"/>
-                <a:ea typeface="Trebuchet MS" pitchFamily="34" charset="-122"/>
-                <a:cs typeface="Trebuchet MS" pitchFamily="34" charset="-120"/>
-              </a:rPr>
-              <a:t>?</a:t>
+              <a:t>How to deploy Kwirth?</a:t>
             </a:r>
             <a:endParaRPr lang="en-US" sz="3600" dirty="0"/>
           </a:p>
@@ -14659,7 +15168,18 @@
                 <a:ea typeface="Consolas" pitchFamily="34" charset="-122"/>
                 <a:cs typeface="Consolas" pitchFamily="34" charset="-120"/>
               </a:rPr>
-              <a:t>kubectl apply -f kwirth.yaml</a:t>
+              <a:t>kubectl apply -f </a:t>
+            </a:r>
+            <a:r>
+              <a:rPr lang="en-US" sz="1100" dirty="0" err="1">
+                <a:solidFill>
+                  <a:srgbClr val="326CE5"/>
+                </a:solidFill>
+                <a:latin typeface="Consolas" pitchFamily="34" charset="0"/>
+                <a:ea typeface="Consolas" pitchFamily="34" charset="-122"/>
+                <a:cs typeface="Consolas" pitchFamily="34" charset="-120"/>
+              </a:rPr>
+              <a:t>kwirth.yaml</a:t>
             </a:r>
             <a:endParaRPr lang="en-US" sz="1100" dirty="0"/>
           </a:p>
@@ -14673,7 +15193,7 @@
         </p:nvSpPr>
         <p:spPr>
           <a:xfrm>
-            <a:off x="530352" y="1856232"/>
+            <a:off x="530352" y="2028825"/>
             <a:ext cx="3657600" cy="594360"/>
           </a:xfrm>
           <a:prstGeom prst="rect">
@@ -14698,51 +15218,7 @@
                 <a:ea typeface="Calibri" pitchFamily="34" charset="-122"/>
                 <a:cs typeface="Calibri" pitchFamily="34" charset="-120"/>
               </a:rPr>
-              <a:t>One only manifest. </a:t>
-            </a:r>
-            <a:r>
-              <a:rPr lang="en-US" sz="1200" dirty="0" err="1">
-                <a:solidFill>
-                  <a:srgbClr val="475569"/>
-                </a:solidFill>
-                <a:latin typeface="Calibri" pitchFamily="34" charset="0"/>
-                <a:ea typeface="Calibri" pitchFamily="34" charset="-122"/>
-                <a:cs typeface="Calibri" pitchFamily="34" charset="-120"/>
-              </a:rPr>
-              <a:t>Kwirth</a:t>
-            </a:r>
-            <a:r>
-              <a:rPr lang="en-US" sz="1200" dirty="0">
-                <a:solidFill>
-                  <a:srgbClr val="475569"/>
-                </a:solidFill>
-                <a:latin typeface="Calibri" pitchFamily="34" charset="0"/>
-                <a:ea typeface="Calibri" pitchFamily="34" charset="-122"/>
-                <a:cs typeface="Calibri" pitchFamily="34" charset="-120"/>
-              </a:rPr>
-              <a:t> runs inside the cluster with direct access to </a:t>
-            </a:r>
-            <a:r>
-              <a:rPr lang="en-US" sz="1200" dirty="0" err="1">
-                <a:solidFill>
-                  <a:srgbClr val="475569"/>
-                </a:solidFill>
-                <a:latin typeface="Calibri" pitchFamily="34" charset="0"/>
-                <a:ea typeface="Calibri" pitchFamily="34" charset="-122"/>
-                <a:cs typeface="Calibri" pitchFamily="34" charset="-120"/>
-              </a:rPr>
-              <a:t>kube</a:t>
-            </a:r>
-            <a:r>
-              <a:rPr lang="en-US" sz="1200" dirty="0">
-                <a:solidFill>
-                  <a:srgbClr val="475569"/>
-                </a:solidFill>
-                <a:latin typeface="Calibri" pitchFamily="34" charset="0"/>
-                <a:ea typeface="Calibri" pitchFamily="34" charset="-122"/>
-                <a:cs typeface="Calibri" pitchFamily="34" charset="-120"/>
-              </a:rPr>
-              <a:t> API.</a:t>
+              <a:t>Kwirth inside-cluster with direct access to Kubernetes API.</a:t>
             </a:r>
             <a:endParaRPr lang="en-US" sz="1200" dirty="0"/>
           </a:p>
@@ -14842,7 +15318,7 @@
                 <a:ea typeface="Trebuchet MS" pitchFamily="34" charset="-122"/>
                 <a:cs typeface="Trebuchet MS" pitchFamily="34" charset="-120"/>
               </a:rPr>
-              <a:t>Helm</a:t>
+              <a:t>Iron</a:t>
             </a:r>
             <a:endParaRPr lang="en-US" sz="1700" dirty="0"/>
           </a:p>
@@ -14953,15 +15429,263 @@
           </a:p>
         </p:txBody>
       </p:sp>
-      <p:sp>
-        <p:nvSpPr>
-          <p:cNvPr id="15" name="Shape 13"/>
-          <p:cNvSpPr/>
-          <p:nvPr/>
-        </p:nvSpPr>
-        <p:spPr>
+      <p:grpSp>
+        <p:nvGrpSpPr>
+          <p:cNvPr id="27" name="Group 26">
+            <a:extLst>
+              <a:ext uri="{FF2B5EF4-FFF2-40B4-BE49-F238E27FC236}">
+                <a16:creationId xmlns:a16="http://schemas.microsoft.com/office/drawing/2014/main" id="{978194B4-80E9-63FB-4C36-6EE93E146760}"/>
+              </a:ext>
+            </a:extLst>
+          </p:cNvPr>
+          <p:cNvGrpSpPr/>
+          <p:nvPr/>
+        </p:nvGrpSpPr>
+        <p:grpSpPr>
           <a:xfrm>
             <a:off x="4663440" y="960120"/>
+            <a:ext cx="4023360" cy="1600200"/>
+            <a:chOff x="4663440" y="960120"/>
+            <a:chExt cx="4023360" cy="1600200"/>
+          </a:xfrm>
+        </p:grpSpPr>
+        <p:sp>
+          <p:nvSpPr>
+            <p:cNvPr id="15" name="Shape 13"/>
+            <p:cNvSpPr/>
+            <p:nvPr/>
+          </p:nvSpPr>
+          <p:spPr>
+            <a:xfrm>
+              <a:off x="4663440" y="960120"/>
+              <a:ext cx="4023360" cy="1600200"/>
+            </a:xfrm>
+            <a:prstGeom prst="rect">
+              <a:avLst/>
+            </a:prstGeom>
+            <a:solidFill>
+              <a:srgbClr val="FFFFFF"/>
+            </a:solidFill>
+            <a:ln/>
+            <a:effectLst>
+              <a:outerShdw blurRad="101600" dist="38100" dir="8100000" algn="bl" rotWithShape="0">
+                <a:srgbClr val="000000">
+                  <a:alpha val="25000"/>
+                </a:srgbClr>
+              </a:outerShdw>
+            </a:effectLst>
+          </p:spPr>
+          <p:txBody>
+            <a:bodyPr/>
+            <a:lstStyle/>
+            <a:p>
+              <a:endParaRPr lang="es-ES"/>
+            </a:p>
+          </p:txBody>
+        </p:sp>
+        <p:sp>
+          <p:nvSpPr>
+            <p:cNvPr id="16" name="Shape 14"/>
+            <p:cNvSpPr/>
+            <p:nvPr/>
+          </p:nvSpPr>
+          <p:spPr>
+            <a:xfrm>
+              <a:off x="4663440" y="960120"/>
+              <a:ext cx="64008" cy="1600200"/>
+            </a:xfrm>
+            <a:prstGeom prst="rect">
+              <a:avLst/>
+            </a:prstGeom>
+            <a:solidFill>
+              <a:srgbClr val="2496ED"/>
+            </a:solidFill>
+            <a:ln/>
+          </p:spPr>
+          <p:txBody>
+            <a:bodyPr/>
+            <a:lstStyle/>
+            <a:p>
+              <a:endParaRPr lang="es-ES"/>
+            </a:p>
+          </p:txBody>
+        </p:sp>
+        <p:sp>
+          <p:nvSpPr>
+            <p:cNvPr id="17" name="Text 15"/>
+            <p:cNvSpPr/>
+            <p:nvPr/>
+          </p:nvSpPr>
+          <p:spPr>
+            <a:xfrm>
+              <a:off x="4828032" y="1051560"/>
+              <a:ext cx="3657600" cy="365760"/>
+            </a:xfrm>
+            <a:prstGeom prst="rect">
+              <a:avLst/>
+            </a:prstGeom>
+            <a:noFill/>
+            <a:ln/>
+          </p:spPr>
+          <p:txBody>
+            <a:bodyPr wrap="square" lIns="0" tIns="0" rIns="0" bIns="0" rtlCol="0" anchor="ctr"/>
+            <a:lstStyle/>
+            <a:p>
+              <a:pPr marL="0" indent="0">
+                <a:buNone/>
+              </a:pPr>
+              <a:r>
+                <a:rPr lang="en-US" sz="1700" b="1" dirty="0">
+                  <a:solidFill>
+                    <a:srgbClr val="0F172A"/>
+                  </a:solidFill>
+                  <a:latin typeface="Trebuchet MS" pitchFamily="34" charset="0"/>
+                  <a:ea typeface="Trebuchet MS" pitchFamily="34" charset="-122"/>
+                  <a:cs typeface="Trebuchet MS" pitchFamily="34" charset="-120"/>
+                </a:rPr>
+                <a:t>Docker</a:t>
+              </a:r>
+              <a:endParaRPr lang="en-US" sz="1700" dirty="0"/>
+            </a:p>
+          </p:txBody>
+        </p:sp>
+        <p:sp>
+          <p:nvSpPr>
+            <p:cNvPr id="18" name="Shape 16"/>
+            <p:cNvSpPr/>
+            <p:nvPr/>
+          </p:nvSpPr>
+          <p:spPr>
+            <a:xfrm>
+              <a:off x="4828032" y="1472184"/>
+              <a:ext cx="3566160" cy="301752"/>
+            </a:xfrm>
+            <a:prstGeom prst="rect">
+              <a:avLst/>
+            </a:prstGeom>
+            <a:solidFill>
+              <a:srgbClr val="F1F5F9"/>
+            </a:solidFill>
+            <a:ln/>
+          </p:spPr>
+          <p:txBody>
+            <a:bodyPr/>
+            <a:lstStyle/>
+            <a:p>
+              <a:endParaRPr lang="es-ES"/>
+            </a:p>
+          </p:txBody>
+        </p:sp>
+        <p:sp>
+          <p:nvSpPr>
+            <p:cNvPr id="19" name="Text 17"/>
+            <p:cNvSpPr/>
+            <p:nvPr/>
+          </p:nvSpPr>
+          <p:spPr>
+            <a:xfrm>
+              <a:off x="4864608" y="1472184"/>
+              <a:ext cx="3520440" cy="301752"/>
+            </a:xfrm>
+            <a:prstGeom prst="rect">
+              <a:avLst/>
+            </a:prstGeom>
+            <a:noFill/>
+            <a:ln/>
+          </p:spPr>
+          <p:txBody>
+            <a:bodyPr wrap="square" lIns="0" tIns="0" rIns="0" bIns="0" rtlCol="0" anchor="ctr"/>
+            <a:lstStyle/>
+            <a:p>
+              <a:pPr marL="0" indent="0">
+                <a:buNone/>
+              </a:pPr>
+              <a:r>
+                <a:rPr lang="en-US" sz="1100" dirty="0">
+                  <a:solidFill>
+                    <a:srgbClr val="2496ED"/>
+                  </a:solidFill>
+                  <a:latin typeface="Consolas" pitchFamily="34" charset="0"/>
+                  <a:ea typeface="Consolas" pitchFamily="34" charset="-122"/>
+                  <a:cs typeface="Consolas" pitchFamily="34" charset="-120"/>
+                </a:rPr>
+                <a:t>docker run kwirthmagnify/kwirth</a:t>
+              </a:r>
+              <a:endParaRPr lang="en-US" sz="1100" dirty="0"/>
+            </a:p>
+          </p:txBody>
+        </p:sp>
+        <p:sp>
+          <p:nvSpPr>
+            <p:cNvPr id="20" name="Text 18"/>
+            <p:cNvSpPr/>
+            <p:nvPr/>
+          </p:nvSpPr>
+          <p:spPr>
+            <a:xfrm>
+              <a:off x="4828032" y="1856232"/>
+              <a:ext cx="3657600" cy="594360"/>
+            </a:xfrm>
+            <a:prstGeom prst="rect">
+              <a:avLst/>
+            </a:prstGeom>
+            <a:noFill/>
+            <a:ln/>
+          </p:spPr>
+          <p:txBody>
+            <a:bodyPr wrap="square" lIns="0" tIns="0" rIns="0" bIns="0" rtlCol="0" anchor="ctr"/>
+            <a:lstStyle/>
+            <a:p>
+              <a:pPr marL="0" indent="0">
+                <a:buNone/>
+              </a:pPr>
+              <a:r>
+                <a:rPr lang="en-US" sz="1200" dirty="0">
+                  <a:solidFill>
+                    <a:srgbClr val="475569"/>
+                  </a:solidFill>
+                  <a:latin typeface="Calibri" pitchFamily="34" charset="0"/>
+                  <a:ea typeface="Calibri" pitchFamily="34" charset="-122"/>
+                  <a:cs typeface="Calibri" pitchFamily="34" charset="-120"/>
+                </a:rPr>
+                <a:t>It is the perfect solution if you want to run Kwirth out-of-cluster, using your own </a:t>
+              </a:r>
+              <a:r>
+                <a:rPr lang="en-US" sz="1200" dirty="0" err="1">
+                  <a:solidFill>
+                    <a:srgbClr val="475569"/>
+                  </a:solidFill>
+                  <a:latin typeface="Calibri" pitchFamily="34" charset="0"/>
+                  <a:ea typeface="Calibri" pitchFamily="34" charset="-122"/>
+                  <a:cs typeface="Calibri" pitchFamily="34" charset="-120"/>
+                </a:rPr>
+                <a:t>kubeconfig</a:t>
+              </a:r>
+              <a:r>
+                <a:rPr lang="en-US" sz="1200" dirty="0">
+                  <a:solidFill>
+                    <a:srgbClr val="475569"/>
+                  </a:solidFill>
+                  <a:latin typeface="Calibri" pitchFamily="34" charset="0"/>
+                  <a:ea typeface="Calibri" pitchFamily="34" charset="-122"/>
+                  <a:cs typeface="Calibri" pitchFamily="34" charset="-120"/>
+                </a:rPr>
+                <a:t>.</a:t>
+              </a:r>
+              <a:endParaRPr lang="en-US" sz="1200" dirty="0"/>
+            </a:p>
+          </p:txBody>
+        </p:sp>
+      </p:grpSp>
+      <p:sp>
+        <p:nvSpPr>
+          <p:cNvPr id="21" name="Shape 19"/>
+          <p:cNvSpPr/>
+          <p:nvPr/>
+        </p:nvSpPr>
+        <p:spPr>
+          <a:xfrm>
+            <a:off x="4663440" y="2834640"/>
             <a:ext cx="4023360" cy="1600200"/>
           </a:xfrm>
           <a:prstGeom prst="rect">
@@ -14989,20 +15713,20 @@
       </p:sp>
       <p:sp>
         <p:nvSpPr>
-          <p:cNvPr id="16" name="Shape 14"/>
-          <p:cNvSpPr/>
-          <p:nvPr/>
-        </p:nvSpPr>
-        <p:spPr>
-          <a:xfrm>
-            <a:off x="4663440" y="960120"/>
+          <p:cNvPr id="22" name="Shape 20"/>
+          <p:cNvSpPr/>
+          <p:nvPr/>
+        </p:nvSpPr>
+        <p:spPr>
+          <a:xfrm>
+            <a:off x="4663440" y="2834640"/>
             <a:ext cx="64008" cy="1600200"/>
           </a:xfrm>
           <a:prstGeom prst="rect">
             <a:avLst/>
           </a:prstGeom>
           <a:solidFill>
-            <a:srgbClr val="2496ED"/>
+            <a:srgbClr val="34D399"/>
           </a:solidFill>
           <a:ln/>
         </p:spPr>
@@ -15016,13 +15740,13 @@
       </p:sp>
       <p:sp>
         <p:nvSpPr>
-          <p:cNvPr id="17" name="Text 15"/>
-          <p:cNvSpPr/>
-          <p:nvPr/>
-        </p:nvSpPr>
-        <p:spPr>
-          <a:xfrm>
-            <a:off x="4828032" y="1051560"/>
+          <p:cNvPr id="23" name="Text 21"/>
+          <p:cNvSpPr/>
+          <p:nvPr/>
+        </p:nvSpPr>
+        <p:spPr>
+          <a:xfrm>
+            <a:off x="4828032" y="2926080"/>
             <a:ext cx="3657600" cy="365760"/>
           </a:xfrm>
           <a:prstGeom prst="rect">
@@ -15047,7 +15771,7 @@
                 <a:ea typeface="Trebuchet MS" pitchFamily="34" charset="-122"/>
                 <a:cs typeface="Trebuchet MS" pitchFamily="34" charset="-120"/>
               </a:rPr>
-              <a:t>Docker</a:t>
+              <a:t>Desktop (Electron)</a:t>
             </a:r>
             <a:endParaRPr lang="en-US" sz="1700" dirty="0"/>
           </a:p>
@@ -15055,13 +15779,13 @@
       </p:sp>
       <p:sp>
         <p:nvSpPr>
-          <p:cNvPr id="18" name="Shape 16"/>
-          <p:cNvSpPr/>
-          <p:nvPr/>
-        </p:nvSpPr>
-        <p:spPr>
-          <a:xfrm>
-            <a:off x="4828032" y="1472184"/>
+          <p:cNvPr id="24" name="Shape 22"/>
+          <p:cNvSpPr/>
+          <p:nvPr/>
+        </p:nvSpPr>
+        <p:spPr>
+          <a:xfrm>
+            <a:off x="4828032" y="3346704"/>
             <a:ext cx="3566160" cy="301752"/>
           </a:xfrm>
           <a:prstGeom prst="rect">
@@ -15082,13 +15806,13 @@
       </p:sp>
       <p:sp>
         <p:nvSpPr>
-          <p:cNvPr id="19" name="Text 17"/>
-          <p:cNvSpPr/>
-          <p:nvPr/>
-        </p:nvSpPr>
-        <p:spPr>
-          <a:xfrm>
-            <a:off x="4864608" y="1472184"/>
+          <p:cNvPr id="25" name="Text 23"/>
+          <p:cNvSpPr/>
+          <p:nvPr/>
+        </p:nvSpPr>
+        <p:spPr>
+          <a:xfrm>
+            <a:off x="4864608" y="3346704"/>
             <a:ext cx="3520440" cy="301752"/>
           </a:xfrm>
           <a:prstGeom prst="rect">
@@ -15107,13 +15831,13 @@
             <a:r>
               <a:rPr lang="en-US" sz="1100" dirty="0">
                 <a:solidFill>
-                  <a:srgbClr val="2496ED"/>
+                  <a:srgbClr val="34D399"/>
                 </a:solidFill>
                 <a:latin typeface="Consolas" pitchFamily="34" charset="0"/>
                 <a:ea typeface="Consolas" pitchFamily="34" charset="-122"/>
                 <a:cs typeface="Consolas" pitchFamily="34" charset="-120"/>
               </a:rPr>
-              <a:t>docker run kwirthmagnify/kwirth</a:t>
+              <a:t>Download from kwirthmagnify.dev</a:t>
             </a:r>
             <a:endParaRPr lang="en-US" sz="1100" dirty="0"/>
           </a:p>
@@ -15121,13 +15845,13 @@
       </p:sp>
       <p:sp>
         <p:nvSpPr>
-          <p:cNvPr id="20" name="Text 18"/>
-          <p:cNvSpPr/>
-          <p:nvPr/>
-        </p:nvSpPr>
-        <p:spPr>
-          <a:xfrm>
-            <a:off x="4828032" y="1856232"/>
+          <p:cNvPr id="26" name="Text 24"/>
+          <p:cNvSpPr/>
+          <p:nvPr/>
+        </p:nvSpPr>
+        <p:spPr>
+          <a:xfrm>
+            <a:off x="4828032" y="3730752"/>
             <a:ext cx="3657600" cy="594360"/>
           </a:xfrm>
           <a:prstGeom prst="rect">
@@ -15152,51 +15876,7 @@
                 <a:ea typeface="Calibri" pitchFamily="34" charset="-122"/>
                 <a:cs typeface="Calibri" pitchFamily="34" charset="-120"/>
               </a:rPr>
-              <a:t>It is the perfect solution if you want to run </a:t>
-            </a:r>
-            <a:r>
-              <a:rPr lang="en-US" sz="1200" dirty="0" err="1">
-                <a:solidFill>
-                  <a:srgbClr val="475569"/>
-                </a:solidFill>
-                <a:latin typeface="Calibri" pitchFamily="34" charset="0"/>
-                <a:ea typeface="Calibri" pitchFamily="34" charset="-122"/>
-                <a:cs typeface="Calibri" pitchFamily="34" charset="-120"/>
-              </a:rPr>
-              <a:t>Kwirth</a:t>
-            </a:r>
-            <a:r>
-              <a:rPr lang="en-US" sz="1200" dirty="0">
-                <a:solidFill>
-                  <a:srgbClr val="475569"/>
-                </a:solidFill>
-                <a:latin typeface="Calibri" pitchFamily="34" charset="0"/>
-                <a:ea typeface="Calibri" pitchFamily="34" charset="-122"/>
-                <a:cs typeface="Calibri" pitchFamily="34" charset="-120"/>
-              </a:rPr>
-              <a:t> out-of-cluster, using your own </a:t>
-            </a:r>
-            <a:r>
-              <a:rPr lang="en-US" sz="1200" dirty="0" err="1">
-                <a:solidFill>
-                  <a:srgbClr val="475569"/>
-                </a:solidFill>
-                <a:latin typeface="Calibri" pitchFamily="34" charset="0"/>
-                <a:ea typeface="Calibri" pitchFamily="34" charset="-122"/>
-                <a:cs typeface="Calibri" pitchFamily="34" charset="-120"/>
-              </a:rPr>
-              <a:t>kubeconfig</a:t>
-            </a:r>
-            <a:r>
-              <a:rPr lang="en-US" sz="1200" dirty="0">
-                <a:solidFill>
-                  <a:srgbClr val="475569"/>
-                </a:solidFill>
-                <a:latin typeface="Calibri" pitchFamily="34" charset="0"/>
-                <a:ea typeface="Calibri" pitchFamily="34" charset="-122"/>
-                <a:cs typeface="Calibri" pitchFamily="34" charset="-120"/>
-              </a:rPr>
-              <a:t>.</a:t>
+              <a:t>Windows &amp; Linux. Like Lens/K9s, but with the power of Kwirth.</a:t>
             </a:r>
             <a:endParaRPr lang="en-US" sz="1200" dirty="0"/>
           </a:p>
@@ -15204,113 +15884,19 @@
       </p:sp>
       <p:sp>
         <p:nvSpPr>
-          <p:cNvPr id="21" name="Shape 19"/>
-          <p:cNvSpPr/>
-          <p:nvPr/>
-        </p:nvSpPr>
-        <p:spPr>
-          <a:xfrm>
-            <a:off x="4663440" y="2834640"/>
-            <a:ext cx="4023360" cy="1600200"/>
-          </a:xfrm>
-          <a:prstGeom prst="rect">
-            <a:avLst/>
-          </a:prstGeom>
-          <a:solidFill>
-            <a:srgbClr val="FFFFFF"/>
-          </a:solidFill>
-          <a:ln/>
-          <a:effectLst>
-            <a:outerShdw blurRad="101600" dist="38100" dir="8100000" algn="bl" rotWithShape="0">
-              <a:srgbClr val="000000">
-                <a:alpha val="25000"/>
-              </a:srgbClr>
-            </a:outerShdw>
-          </a:effectLst>
-        </p:spPr>
-        <p:txBody>
-          <a:bodyPr/>
-          <a:lstStyle/>
-          <a:p>
-            <a:endParaRPr lang="es-ES"/>
-          </a:p>
-        </p:txBody>
-      </p:sp>
-      <p:sp>
-        <p:nvSpPr>
-          <p:cNvPr id="22" name="Shape 20"/>
-          <p:cNvSpPr/>
-          <p:nvPr/>
-        </p:nvSpPr>
-        <p:spPr>
-          <a:xfrm>
-            <a:off x="4663440" y="2834640"/>
-            <a:ext cx="64008" cy="1600200"/>
-          </a:xfrm>
-          <a:prstGeom prst="rect">
-            <a:avLst/>
-          </a:prstGeom>
-          <a:solidFill>
-            <a:srgbClr val="34D399"/>
-          </a:solidFill>
-          <a:ln/>
-        </p:spPr>
-        <p:txBody>
-          <a:bodyPr/>
-          <a:lstStyle/>
-          <a:p>
-            <a:endParaRPr lang="es-ES"/>
-          </a:p>
-        </p:txBody>
-      </p:sp>
-      <p:sp>
-        <p:nvSpPr>
-          <p:cNvPr id="23" name="Text 21"/>
-          <p:cNvSpPr/>
-          <p:nvPr/>
-        </p:nvSpPr>
-        <p:spPr>
-          <a:xfrm>
-            <a:off x="4828032" y="2926080"/>
-            <a:ext cx="3657600" cy="365760"/>
-          </a:xfrm>
-          <a:prstGeom prst="rect">
-            <a:avLst/>
-          </a:prstGeom>
-          <a:noFill/>
-          <a:ln/>
-        </p:spPr>
-        <p:txBody>
-          <a:bodyPr wrap="square" lIns="0" tIns="0" rIns="0" bIns="0" rtlCol="0" anchor="ctr"/>
-          <a:lstStyle/>
-          <a:p>
-            <a:pPr marL="0" indent="0">
-              <a:buNone/>
-            </a:pPr>
-            <a:r>
-              <a:rPr lang="en-US" sz="1700" b="1" dirty="0">
-                <a:solidFill>
-                  <a:srgbClr val="0F172A"/>
-                </a:solidFill>
-                <a:latin typeface="Trebuchet MS" pitchFamily="34" charset="0"/>
-                <a:ea typeface="Trebuchet MS" pitchFamily="34" charset="-122"/>
-                <a:cs typeface="Trebuchet MS" pitchFamily="34" charset="-120"/>
-              </a:rPr>
-              <a:t>Desktop (Electron)</a:t>
-            </a:r>
-            <a:endParaRPr lang="en-US" sz="1700" dirty="0"/>
-          </a:p>
-        </p:txBody>
-      </p:sp>
-      <p:sp>
-        <p:nvSpPr>
-          <p:cNvPr id="24" name="Shape 22"/>
-          <p:cNvSpPr/>
-          <p:nvPr/>
-        </p:nvSpPr>
-        <p:spPr>
-          <a:xfrm>
-            <a:off x="4828032" y="3346704"/>
+          <p:cNvPr id="29" name="Shape 4">
+            <a:extLst>
+              <a:ext uri="{FF2B5EF4-FFF2-40B4-BE49-F238E27FC236}">
+                <a16:creationId xmlns:a16="http://schemas.microsoft.com/office/drawing/2014/main" id="{92F21A8D-4AB9-C353-9664-C399203E5044}"/>
+              </a:ext>
+            </a:extLst>
+          </p:cNvPr>
+          <p:cNvSpPr/>
+          <p:nvPr/>
+        </p:nvSpPr>
+        <p:spPr>
+          <a:xfrm>
+            <a:off x="521208" y="1828800"/>
             <a:ext cx="3566160" cy="301752"/>
           </a:xfrm>
           <a:prstGeom prst="rect">
@@ -15331,13 +15917,19 @@
       </p:sp>
       <p:sp>
         <p:nvSpPr>
-          <p:cNvPr id="25" name="Text 23"/>
-          <p:cNvSpPr/>
-          <p:nvPr/>
-        </p:nvSpPr>
-        <p:spPr>
-          <a:xfrm>
-            <a:off x="4864608" y="3346704"/>
+          <p:cNvPr id="30" name="Text 5">
+            <a:extLst>
+              <a:ext uri="{FF2B5EF4-FFF2-40B4-BE49-F238E27FC236}">
+                <a16:creationId xmlns:a16="http://schemas.microsoft.com/office/drawing/2014/main" id="{7D2E2A17-07FD-FB9E-1EBE-E953FDCC5819}"/>
+              </a:ext>
+            </a:extLst>
+          </p:cNvPr>
+          <p:cNvSpPr/>
+          <p:nvPr/>
+        </p:nvSpPr>
+        <p:spPr>
+          <a:xfrm>
+            <a:off x="557784" y="1828800"/>
             <a:ext cx="3520440" cy="301752"/>
           </a:xfrm>
           <a:prstGeom prst="rect">
@@ -15356,98 +15948,31 @@
             <a:r>
               <a:rPr lang="en-US" sz="1100" dirty="0">
                 <a:solidFill>
-                  <a:srgbClr val="34D399"/>
+                  <a:srgbClr val="326CE5"/>
                 </a:solidFill>
                 <a:latin typeface="Consolas" pitchFamily="34" charset="0"/>
                 <a:ea typeface="Consolas" pitchFamily="34" charset="-122"/>
                 <a:cs typeface="Consolas" pitchFamily="34" charset="-120"/>
               </a:rPr>
-              <a:t>Download </a:t>
-            </a:r>
-            <a:r>
-              <a:rPr lang="en-US" sz="1100" dirty="0" err="1">
-                <a:solidFill>
-                  <a:srgbClr val="34D399"/>
+              <a:t>helm install kwirth kwirth/kwirth -n kwirth \</a:t>
+            </a:r>
+          </a:p>
+          <a:p>
+            <a:pPr marL="0" indent="0">
+              <a:buNone/>
+            </a:pPr>
+            <a:r>
+              <a:rPr lang="en-US" sz="1100" dirty="0">
+                <a:solidFill>
+                  <a:srgbClr val="326CE5"/>
                 </a:solidFill>
                 <a:latin typeface="Consolas" pitchFamily="34" charset="0"/>
                 <a:ea typeface="Consolas" pitchFamily="34" charset="-122"/>
                 <a:cs typeface="Consolas" pitchFamily="34" charset="-120"/>
               </a:rPr>
-              <a:t>en</a:t>
-            </a:r>
-            <a:r>
-              <a:rPr lang="en-US" sz="1100" dirty="0">
-                <a:solidFill>
-                  <a:srgbClr val="34D399"/>
-                </a:solidFill>
-                <a:latin typeface="Consolas" pitchFamily="34" charset="0"/>
-                <a:ea typeface="Consolas" pitchFamily="34" charset="-122"/>
-                <a:cs typeface="Consolas" pitchFamily="34" charset="-120"/>
-              </a:rPr>
-              <a:t> kwirthmagnify.dev</a:t>
+              <a:t>  --create-namespace</a:t>
             </a:r>
             <a:endParaRPr lang="en-US" sz="1100" dirty="0"/>
-          </a:p>
-        </p:txBody>
-      </p:sp>
-      <p:sp>
-        <p:nvSpPr>
-          <p:cNvPr id="26" name="Text 24"/>
-          <p:cNvSpPr/>
-          <p:nvPr/>
-        </p:nvSpPr>
-        <p:spPr>
-          <a:xfrm>
-            <a:off x="4828032" y="3730752"/>
-            <a:ext cx="3657600" cy="594360"/>
-          </a:xfrm>
-          <a:prstGeom prst="rect">
-            <a:avLst/>
-          </a:prstGeom>
-          <a:noFill/>
-          <a:ln/>
-        </p:spPr>
-        <p:txBody>
-          <a:bodyPr wrap="square" lIns="0" tIns="0" rIns="0" bIns="0" rtlCol="0" anchor="ctr"/>
-          <a:lstStyle/>
-          <a:p>
-            <a:pPr marL="0" indent="0">
-              <a:buNone/>
-            </a:pPr>
-            <a:r>
-              <a:rPr lang="en-US" sz="1200" dirty="0">
-                <a:solidFill>
-                  <a:srgbClr val="475569"/>
-                </a:solidFill>
-                <a:latin typeface="Calibri" pitchFamily="34" charset="0"/>
-                <a:ea typeface="Calibri" pitchFamily="34" charset="-122"/>
-                <a:cs typeface="Calibri" pitchFamily="34" charset="-120"/>
-              </a:rPr>
-              <a:t>Windows &amp; Linux. Like Lens/K9s, but with the power of </a:t>
-            </a:r>
-            <a:r>
-              <a:rPr lang="en-US" sz="1200" dirty="0" err="1">
-                <a:solidFill>
-                  <a:srgbClr val="475569"/>
-                </a:solidFill>
-                <a:latin typeface="Calibri" pitchFamily="34" charset="0"/>
-                <a:ea typeface="Calibri" pitchFamily="34" charset="-122"/>
-                <a:cs typeface="Calibri" pitchFamily="34" charset="-120"/>
-              </a:rPr>
-              <a:t>Kwirth</a:t>
-            </a:r>
-            <a:r>
-              <a:rPr lang="en-US" sz="1200" dirty="0">
-                <a:solidFill>
-                  <a:srgbClr val="475569"/>
-                </a:solidFill>
-                <a:latin typeface="Calibri" pitchFamily="34" charset="0"/>
-                <a:ea typeface="Calibri" pitchFamily="34" charset="-122"/>
-                <a:cs typeface="Calibri" pitchFamily="34" charset="-120"/>
-              </a:rPr>
-              <a:t>.</a:t>
-            </a:r>
-            <a:endParaRPr lang="en-US" sz="1200" dirty="0"/>
           </a:p>
         </p:txBody>
       </p:sp>
@@ -15461,15 +15986,7 @@
 
 <file path=ppt/slides/slide9.xml><?xml version="1.0" encoding="utf-8"?>
 <p:sld xmlns:a="http://schemas.openxmlformats.org/drawingml/2006/main" xmlns:r="http://schemas.openxmlformats.org/officeDocument/2006/relationships" xmlns:p="http://schemas.openxmlformats.org/presentationml/2006/main">
-  <p:cSld name="Slide 9">
-    <p:bg>
-      <p:bgPr>
-        <a:solidFill>
-          <a:srgbClr val="0F172A"/>
-        </a:solidFill>
-        <a:effectLst/>
-      </p:bgPr>
-    </p:bg>
+  <p:cSld>
     <p:spTree>
       <p:nvGrpSpPr>
         <p:cNvPr id="1" name=""/>
@@ -15486,79 +16003,19 @@
       </p:grpSpPr>
       <p:sp>
         <p:nvSpPr>
-          <p:cNvPr id="2" name="Shape 0"/>
-          <p:cNvSpPr/>
-          <p:nvPr/>
-        </p:nvSpPr>
-        <p:spPr>
-          <a:xfrm>
-            <a:off x="0" y="0"/>
-            <a:ext cx="9144000" cy="5143500"/>
-          </a:xfrm>
-          <a:prstGeom prst="rect">
-            <a:avLst/>
-          </a:prstGeom>
-          <a:solidFill>
-            <a:srgbClr val="0C1829"/>
-          </a:solidFill>
-          <a:ln/>
-        </p:spPr>
-        <p:txBody>
-          <a:bodyPr/>
-          <a:lstStyle/>
-          <a:p>
-            <a:endParaRPr lang="es-ES"/>
-          </a:p>
-        </p:txBody>
-      </p:sp>
-      <p:sp>
-        <p:nvSpPr>
-          <p:cNvPr id="3" name="Text 1"/>
-          <p:cNvSpPr/>
-          <p:nvPr/>
-        </p:nvSpPr>
-        <p:spPr>
-          <a:xfrm>
-            <a:off x="457200" y="385354"/>
-            <a:ext cx="8229600" cy="914400"/>
-          </a:xfrm>
-          <a:prstGeom prst="rect">
-            <a:avLst/>
-          </a:prstGeom>
-          <a:noFill/>
-          <a:ln/>
-        </p:spPr>
-        <p:txBody>
-          <a:bodyPr wrap="square" lIns="0" tIns="0" rIns="0" bIns="0" rtlCol="0" anchor="ctr"/>
-          <a:lstStyle/>
-          <a:p>
-            <a:pPr marL="0" indent="0" algn="ctr">
-              <a:buNone/>
-            </a:pPr>
-            <a:r>
-              <a:rPr lang="en-US" sz="7200" b="1" kern="0" spc="800" dirty="0">
-                <a:solidFill>
-                  <a:srgbClr val="38BDF8"/>
-                </a:solidFill>
-                <a:latin typeface="Consolas" pitchFamily="34" charset="0"/>
-                <a:ea typeface="Consolas" pitchFamily="34" charset="-122"/>
-                <a:cs typeface="Consolas" pitchFamily="34" charset="-120"/>
-              </a:rPr>
-              <a:t>[ DEMO ]</a:t>
-            </a:r>
-            <a:endParaRPr lang="en-US" sz="7200" dirty="0"/>
-          </a:p>
-        </p:txBody>
-      </p:sp>
-      <p:sp>
-        <p:nvSpPr>
-          <p:cNvPr id="4" name="Text 2"/>
-          <p:cNvSpPr/>
-          <p:nvPr/>
-        </p:nvSpPr>
-        <p:spPr>
-          <a:xfrm>
-            <a:off x="457200" y="1391194"/>
+          <p:cNvPr id="2" name="Text 0">
+            <a:extLst>
+              <a:ext uri="{FF2B5EF4-FFF2-40B4-BE49-F238E27FC236}">
+                <a16:creationId xmlns:a16="http://schemas.microsoft.com/office/drawing/2014/main" id="{C0D03269-BCA1-B8E7-39AD-08D42718A4C2}"/>
+              </a:ext>
+            </a:extLst>
+          </p:cNvPr>
+          <p:cNvSpPr/>
+          <p:nvPr/>
+        </p:nvSpPr>
+        <p:spPr>
+          <a:xfrm>
+            <a:off x="457200" y="228600"/>
             <a:ext cx="8229600" cy="502920"/>
           </a:xfrm>
           <a:prstGeom prst="rect">
@@ -15571,316 +16028,636 @@
           <a:bodyPr wrap="square" lIns="0" tIns="0" rIns="0" bIns="0" rtlCol="0" anchor="ctr"/>
           <a:lstStyle/>
           <a:p>
-            <a:pPr marL="0" indent="0" algn="ctr">
-              <a:buNone/>
-            </a:pPr>
-            <a:r>
-              <a:rPr lang="en-US" sz="2800" dirty="0">
-                <a:solidFill>
-                  <a:srgbClr val="FFFFFF"/>
+            <a:pPr marL="0" indent="0">
+              <a:buNone/>
+            </a:pPr>
+            <a:r>
+              <a:rPr lang="en-US" sz="3600" b="1" dirty="0">
+                <a:solidFill>
+                  <a:srgbClr val="0F172A"/>
                 </a:solidFill>
                 <a:latin typeface="Trebuchet MS" pitchFamily="34" charset="0"/>
                 <a:ea typeface="Trebuchet MS" pitchFamily="34" charset="-122"/>
                 <a:cs typeface="Trebuchet MS" pitchFamily="34" charset="-120"/>
               </a:rPr>
-              <a:t>Let’s see </a:t>
-            </a:r>
-            <a:r>
-              <a:rPr lang="en-US" sz="2800" dirty="0" err="1">
-                <a:solidFill>
-                  <a:srgbClr val="FFFFFF"/>
+              <a:t>Kwirth family</a:t>
+            </a:r>
+            <a:endParaRPr lang="en-US" sz="3600" dirty="0"/>
+          </a:p>
+        </p:txBody>
+      </p:sp>
+      <p:pic>
+        <p:nvPicPr>
+          <p:cNvPr id="4" name="Picture 3">
+            <a:extLst>
+              <a:ext uri="{FF2B5EF4-FFF2-40B4-BE49-F238E27FC236}">
+                <a16:creationId xmlns:a16="http://schemas.microsoft.com/office/drawing/2014/main" id="{B3C7B1F8-BF48-4CFB-FC54-C1719C13CC3E}"/>
+              </a:ext>
+            </a:extLst>
+          </p:cNvPr>
+          <p:cNvPicPr>
+            <a:picLocks noChangeAspect="1"/>
+          </p:cNvPicPr>
+          <p:nvPr/>
+        </p:nvPicPr>
+        <p:blipFill>
+          <a:blip r:embed="rId2"/>
+          <a:stretch>
+            <a:fillRect/>
+          </a:stretch>
+        </p:blipFill>
+        <p:spPr>
+          <a:xfrm>
+            <a:off x="333375" y="753305"/>
+            <a:ext cx="6149734" cy="4390195"/>
+          </a:xfrm>
+          <a:prstGeom prst="rect">
+            <a:avLst/>
+          </a:prstGeom>
+        </p:spPr>
+      </p:pic>
+      <p:sp>
+        <p:nvSpPr>
+          <p:cNvPr id="9" name="Oval 8">
+            <a:extLst>
+              <a:ext uri="{FF2B5EF4-FFF2-40B4-BE49-F238E27FC236}">
+                <a16:creationId xmlns:a16="http://schemas.microsoft.com/office/drawing/2014/main" id="{E9354C61-8495-5C43-0503-FC6206CE90F8}"/>
+              </a:ext>
+            </a:extLst>
+          </p:cNvPr>
+          <p:cNvSpPr/>
+          <p:nvPr/>
+        </p:nvSpPr>
+        <p:spPr>
+          <a:xfrm>
+            <a:off x="3020314" y="3241962"/>
+            <a:ext cx="914400" cy="914400"/>
+          </a:xfrm>
+          <a:prstGeom prst="ellipse">
+            <a:avLst/>
+          </a:prstGeom>
+          <a:solidFill>
+            <a:srgbClr val="FF0000">
+              <a:alpha val="26000"/>
+            </a:srgbClr>
+          </a:solidFill>
+          <a:ln w="38100">
+            <a:solidFill>
+              <a:srgbClr val="7030A0"/>
+            </a:solidFill>
+          </a:ln>
+        </p:spPr>
+        <p:style>
+          <a:lnRef idx="2">
+            <a:schemeClr val="accent1">
+              <a:shade val="15000"/>
+            </a:schemeClr>
+          </a:lnRef>
+          <a:fillRef idx="1">
+            <a:schemeClr val="accent1"/>
+          </a:fillRef>
+          <a:effectRef idx="0">
+            <a:schemeClr val="accent1"/>
+          </a:effectRef>
+          <a:fontRef idx="minor">
+            <a:schemeClr val="lt1"/>
+          </a:fontRef>
+        </p:style>
+        <p:txBody>
+          <a:bodyPr rtlCol="0" anchor="ctr"/>
+          <a:lstStyle/>
+          <a:p>
+            <a:pPr algn="ctr"/>
+            <a:endParaRPr lang="es-ES"/>
+          </a:p>
+        </p:txBody>
+      </p:sp>
+      <p:sp>
+        <p:nvSpPr>
+          <p:cNvPr id="10" name="Oval 9">
+            <a:extLst>
+              <a:ext uri="{FF2B5EF4-FFF2-40B4-BE49-F238E27FC236}">
+                <a16:creationId xmlns:a16="http://schemas.microsoft.com/office/drawing/2014/main" id="{DB2C1692-902F-FDFB-DF1E-BC171DCB62C0}"/>
+              </a:ext>
+            </a:extLst>
+          </p:cNvPr>
+          <p:cNvSpPr/>
+          <p:nvPr/>
+        </p:nvSpPr>
+        <p:spPr>
+          <a:xfrm>
+            <a:off x="1413187" y="4206759"/>
+            <a:ext cx="731520" cy="731520"/>
+          </a:xfrm>
+          <a:prstGeom prst="ellipse">
+            <a:avLst/>
+          </a:prstGeom>
+          <a:solidFill>
+            <a:srgbClr val="FF0000">
+              <a:alpha val="26000"/>
+            </a:srgbClr>
+          </a:solidFill>
+          <a:ln w="38100">
+            <a:solidFill>
+              <a:srgbClr val="7030A0"/>
+            </a:solidFill>
+          </a:ln>
+        </p:spPr>
+        <p:style>
+          <a:lnRef idx="2">
+            <a:schemeClr val="accent1">
+              <a:shade val="15000"/>
+            </a:schemeClr>
+          </a:lnRef>
+          <a:fillRef idx="1">
+            <a:schemeClr val="accent1"/>
+          </a:fillRef>
+          <a:effectRef idx="0">
+            <a:schemeClr val="accent1"/>
+          </a:effectRef>
+          <a:fontRef idx="minor">
+            <a:schemeClr val="lt1"/>
+          </a:fontRef>
+        </p:style>
+        <p:txBody>
+          <a:bodyPr rtlCol="0" anchor="ctr"/>
+          <a:lstStyle/>
+          <a:p>
+            <a:pPr algn="ctr"/>
+            <a:endParaRPr lang="es-ES"/>
+          </a:p>
+        </p:txBody>
+      </p:sp>
+      <p:grpSp>
+        <p:nvGrpSpPr>
+          <p:cNvPr id="26" name="Group 25">
+            <a:extLst>
+              <a:ext uri="{FF2B5EF4-FFF2-40B4-BE49-F238E27FC236}">
+                <a16:creationId xmlns:a16="http://schemas.microsoft.com/office/drawing/2014/main" id="{7C8161B4-B952-F838-5547-30EBD29AA230}"/>
+              </a:ext>
+            </a:extLst>
+          </p:cNvPr>
+          <p:cNvGrpSpPr/>
+          <p:nvPr/>
+        </p:nvGrpSpPr>
+        <p:grpSpPr>
+          <a:xfrm>
+            <a:off x="6911416" y="935576"/>
+            <a:ext cx="1973580" cy="3595255"/>
+            <a:chOff x="7018020" y="669867"/>
+            <a:chExt cx="1600200" cy="4023360"/>
+          </a:xfrm>
+        </p:grpSpPr>
+        <p:sp>
+          <p:nvSpPr>
+            <p:cNvPr id="19" name="Shape 13">
+              <a:extLst>
+                <a:ext uri="{FF2B5EF4-FFF2-40B4-BE49-F238E27FC236}">
+                  <a16:creationId xmlns:a16="http://schemas.microsoft.com/office/drawing/2014/main" id="{8732044A-D78B-83B3-0F82-D5DA29C3F70A}"/>
+                </a:ext>
+              </a:extLst>
+            </p:cNvPr>
+            <p:cNvSpPr/>
+            <p:nvPr/>
+          </p:nvSpPr>
+          <p:spPr>
+            <a:xfrm rot="5400000">
+              <a:off x="5806440" y="1881447"/>
+              <a:ext cx="4023360" cy="1600200"/>
+            </a:xfrm>
+            <a:prstGeom prst="rect">
+              <a:avLst/>
+            </a:prstGeom>
+            <a:solidFill>
+              <a:srgbClr val="FFFFFF"/>
+            </a:solidFill>
+            <a:ln/>
+            <a:effectLst>
+              <a:outerShdw blurRad="101600" dist="38100" dir="8100000" algn="bl" rotWithShape="0">
+                <a:srgbClr val="000000">
+                  <a:alpha val="25000"/>
+                </a:srgbClr>
+              </a:outerShdw>
+            </a:effectLst>
+          </p:spPr>
+          <p:txBody>
+            <a:bodyPr/>
+            <a:lstStyle/>
+            <a:p>
+              <a:endParaRPr lang="es-ES"/>
+            </a:p>
+          </p:txBody>
+        </p:sp>
+        <p:sp>
+          <p:nvSpPr>
+            <p:cNvPr id="20" name="Shape 14">
+              <a:extLst>
+                <a:ext uri="{FF2B5EF4-FFF2-40B4-BE49-F238E27FC236}">
+                  <a16:creationId xmlns:a16="http://schemas.microsoft.com/office/drawing/2014/main" id="{D840B8ED-9F2D-8F59-A947-2E38AC8974AF}"/>
+                </a:ext>
+              </a:extLst>
+            </p:cNvPr>
+            <p:cNvSpPr/>
+            <p:nvPr/>
+          </p:nvSpPr>
+          <p:spPr>
+            <a:xfrm rot="5400000">
+              <a:off x="7786116" y="-98229"/>
+              <a:ext cx="64008" cy="1600200"/>
+            </a:xfrm>
+            <a:prstGeom prst="rect">
+              <a:avLst/>
+            </a:prstGeom>
+            <a:solidFill>
+              <a:srgbClr val="2496ED"/>
+            </a:solidFill>
+            <a:ln/>
+          </p:spPr>
+          <p:txBody>
+            <a:bodyPr/>
+            <a:lstStyle/>
+            <a:p>
+              <a:endParaRPr lang="es-ES"/>
+            </a:p>
+          </p:txBody>
+        </p:sp>
+      </p:grpSp>
+      <p:sp>
+        <p:nvSpPr>
+          <p:cNvPr id="21" name="Text 15">
+            <a:extLst>
+              <a:ext uri="{FF2B5EF4-FFF2-40B4-BE49-F238E27FC236}">
+                <a16:creationId xmlns:a16="http://schemas.microsoft.com/office/drawing/2014/main" id="{853458E5-398B-BD37-E2F2-34A8D6CD6DA6}"/>
+              </a:ext>
+            </a:extLst>
+          </p:cNvPr>
+          <p:cNvSpPr/>
+          <p:nvPr/>
+        </p:nvSpPr>
+        <p:spPr>
+          <a:xfrm>
+            <a:off x="6911416" y="1144087"/>
+            <a:ext cx="1973580" cy="365760"/>
+          </a:xfrm>
+          <a:prstGeom prst="rect">
+            <a:avLst/>
+          </a:prstGeom>
+          <a:noFill/>
+          <a:ln/>
+        </p:spPr>
+        <p:txBody>
+          <a:bodyPr wrap="square" lIns="0" tIns="0" rIns="0" bIns="0" rtlCol="0" anchor="ctr"/>
+          <a:lstStyle/>
+          <a:p>
+            <a:pPr marL="0" indent="0" algn="ctr">
+              <a:buNone/>
+            </a:pPr>
+            <a:r>
+              <a:rPr lang="en-US" sz="1700" b="1" dirty="0">
+                <a:solidFill>
+                  <a:srgbClr val="0F172A"/>
                 </a:solidFill>
                 <a:latin typeface="Trebuchet MS" pitchFamily="34" charset="0"/>
                 <a:ea typeface="Trebuchet MS" pitchFamily="34" charset="-122"/>
                 <a:cs typeface="Trebuchet MS" pitchFamily="34" charset="-120"/>
               </a:rPr>
-              <a:t>Kwirth</a:t>
-            </a:r>
-            <a:r>
-              <a:rPr lang="en-US" sz="2800" dirty="0">
-                <a:solidFill>
-                  <a:srgbClr val="FFFFFF"/>
-                </a:solidFill>
-                <a:latin typeface="Trebuchet MS" pitchFamily="34" charset="0"/>
-                <a:ea typeface="Trebuchet MS" pitchFamily="34" charset="-122"/>
-                <a:cs typeface="Trebuchet MS" pitchFamily="34" charset="-120"/>
-              </a:rPr>
-              <a:t> in action 🚀</a:t>
-            </a:r>
-            <a:endParaRPr lang="en-US" sz="2800" dirty="0"/>
-          </a:p>
-        </p:txBody>
-      </p:sp>
-      <p:sp>
-        <p:nvSpPr>
-          <p:cNvPr id="5" name="Shape 3"/>
-          <p:cNvSpPr/>
-          <p:nvPr/>
-        </p:nvSpPr>
-        <p:spPr>
-          <a:xfrm>
-            <a:off x="1371600" y="2076994"/>
-            <a:ext cx="6400800" cy="438912"/>
-          </a:xfrm>
-          <a:prstGeom prst="rect">
-            <a:avLst/>
-          </a:prstGeom>
-          <a:solidFill>
-            <a:srgbClr val="1E293B"/>
-          </a:solidFill>
-          <a:ln/>
-        </p:spPr>
-        <p:txBody>
-          <a:bodyPr/>
-          <a:lstStyle/>
-          <a:p>
-            <a:endParaRPr lang="es-ES"/>
-          </a:p>
-        </p:txBody>
-      </p:sp>
-      <p:sp>
-        <p:nvSpPr>
-          <p:cNvPr id="6" name="Text 4"/>
-          <p:cNvSpPr/>
-          <p:nvPr/>
-        </p:nvSpPr>
-        <p:spPr>
-          <a:xfrm>
-            <a:off x="1554480" y="2076994"/>
-            <a:ext cx="6035040" cy="438912"/>
-          </a:xfrm>
-          <a:prstGeom prst="rect">
-            <a:avLst/>
-          </a:prstGeom>
-          <a:noFill/>
-          <a:ln/>
-        </p:spPr>
-        <p:txBody>
-          <a:bodyPr wrap="square" lIns="0" tIns="0" rIns="0" bIns="0" rtlCol="0" anchor="ctr"/>
-          <a:lstStyle/>
-          <a:p>
-            <a:pPr marL="0" indent="0">
-              <a:buNone/>
-            </a:pPr>
-            <a:r>
-              <a:rPr lang="en-US" sz="1500" dirty="0">
-                <a:solidFill>
-                  <a:srgbClr val="E2E8F0"/>
+              <a:t>Deployment</a:t>
+            </a:r>
+            <a:endParaRPr lang="en-US" sz="1700" dirty="0"/>
+          </a:p>
+        </p:txBody>
+      </p:sp>
+      <p:grpSp>
+        <p:nvGrpSpPr>
+          <p:cNvPr id="25" name="Group 24">
+            <a:extLst>
+              <a:ext uri="{FF2B5EF4-FFF2-40B4-BE49-F238E27FC236}">
+                <a16:creationId xmlns:a16="http://schemas.microsoft.com/office/drawing/2014/main" id="{E33B5BE4-9F5D-12AC-C4C8-FF4B6F914BFE}"/>
+              </a:ext>
+            </a:extLst>
+          </p:cNvPr>
+          <p:cNvGrpSpPr/>
+          <p:nvPr/>
+        </p:nvGrpSpPr>
+        <p:grpSpPr>
+          <a:xfrm>
+            <a:off x="7018096" y="1654350"/>
+            <a:ext cx="1771651" cy="792584"/>
+            <a:chOff x="6172200" y="2466663"/>
+            <a:chExt cx="3566160" cy="315468"/>
+          </a:xfrm>
+        </p:grpSpPr>
+        <p:sp>
+          <p:nvSpPr>
+            <p:cNvPr id="22" name="Shape 16">
+              <a:extLst>
+                <a:ext uri="{FF2B5EF4-FFF2-40B4-BE49-F238E27FC236}">
+                  <a16:creationId xmlns:a16="http://schemas.microsoft.com/office/drawing/2014/main" id="{6DA16921-9E13-BB5B-D218-5CCB757AA4DA}"/>
+                </a:ext>
+              </a:extLst>
+            </p:cNvPr>
+            <p:cNvSpPr/>
+            <p:nvPr/>
+          </p:nvSpPr>
+          <p:spPr>
+            <a:xfrm>
+              <a:off x="6172200" y="2466663"/>
+              <a:ext cx="3566160" cy="301752"/>
+            </a:xfrm>
+            <a:prstGeom prst="rect">
+              <a:avLst/>
+            </a:prstGeom>
+            <a:solidFill>
+              <a:srgbClr val="F1F5F9"/>
+            </a:solidFill>
+            <a:ln/>
+          </p:spPr>
+          <p:txBody>
+            <a:bodyPr/>
+            <a:lstStyle/>
+            <a:p>
+              <a:endParaRPr lang="es-ES"/>
+            </a:p>
+          </p:txBody>
+        </p:sp>
+        <p:sp>
+          <p:nvSpPr>
+            <p:cNvPr id="23" name="Text 17">
+              <a:extLst>
+                <a:ext uri="{FF2B5EF4-FFF2-40B4-BE49-F238E27FC236}">
+                  <a16:creationId xmlns:a16="http://schemas.microsoft.com/office/drawing/2014/main" id="{22FD3A38-B55F-426F-E44C-A7DA41CCD323}"/>
+                </a:ext>
+              </a:extLst>
+            </p:cNvPr>
+            <p:cNvSpPr/>
+            <p:nvPr/>
+          </p:nvSpPr>
+          <p:spPr>
+            <a:xfrm>
+              <a:off x="6402273" y="2480379"/>
+              <a:ext cx="3313229" cy="301752"/>
+            </a:xfrm>
+            <a:prstGeom prst="rect">
+              <a:avLst/>
+            </a:prstGeom>
+            <a:noFill/>
+            <a:ln/>
+          </p:spPr>
+          <p:txBody>
+            <a:bodyPr wrap="square" lIns="0" tIns="0" rIns="0" bIns="0" rtlCol="0" anchor="ctr"/>
+            <a:lstStyle/>
+            <a:p>
+              <a:pPr marL="0" indent="0">
+                <a:buNone/>
+              </a:pPr>
+              <a:r>
+                <a:rPr lang="en-US" sz="1200" dirty="0">
+                  <a:solidFill>
+                    <a:srgbClr val="475569"/>
+                  </a:solidFill>
+                  <a:latin typeface="Calibri" pitchFamily="34" charset="0"/>
+                  <a:ea typeface="Calibri" pitchFamily="34" charset="-122"/>
+                  <a:cs typeface="Calibri" pitchFamily="34" charset="-120"/>
+                </a:rPr>
+                <a:t>Same codebase, three different deployment options</a:t>
+              </a:r>
+            </a:p>
+            <a:p>
+              <a:pPr marL="0" indent="0">
+                <a:buNone/>
+              </a:pPr>
+              <a:endParaRPr lang="en-US" sz="1100" dirty="0"/>
+            </a:p>
+          </p:txBody>
+        </p:sp>
+      </p:grpSp>
+      <p:grpSp>
+        <p:nvGrpSpPr>
+          <p:cNvPr id="27" name="Group 26">
+            <a:extLst>
+              <a:ext uri="{FF2B5EF4-FFF2-40B4-BE49-F238E27FC236}">
+                <a16:creationId xmlns:a16="http://schemas.microsoft.com/office/drawing/2014/main" id="{1CFD1558-074B-0E66-B968-F759D86BA4BC}"/>
+              </a:ext>
+            </a:extLst>
+          </p:cNvPr>
+          <p:cNvGrpSpPr/>
+          <p:nvPr/>
+        </p:nvGrpSpPr>
+        <p:grpSpPr>
+          <a:xfrm>
+            <a:off x="7029453" y="2639753"/>
+            <a:ext cx="1771651" cy="792587"/>
+            <a:chOff x="6172200" y="2466662"/>
+            <a:chExt cx="3566160" cy="315469"/>
+          </a:xfrm>
+        </p:grpSpPr>
+        <p:sp>
+          <p:nvSpPr>
+            <p:cNvPr id="28" name="Shape 16">
+              <a:extLst>
+                <a:ext uri="{FF2B5EF4-FFF2-40B4-BE49-F238E27FC236}">
+                  <a16:creationId xmlns:a16="http://schemas.microsoft.com/office/drawing/2014/main" id="{D8717606-5F9D-D851-B8AD-4504DF00F458}"/>
+                </a:ext>
+              </a:extLst>
+            </p:cNvPr>
+            <p:cNvSpPr/>
+            <p:nvPr/>
+          </p:nvSpPr>
+          <p:spPr>
+            <a:xfrm>
+              <a:off x="6172200" y="2466662"/>
+              <a:ext cx="3566160" cy="301752"/>
+            </a:xfrm>
+            <a:prstGeom prst="rect">
+              <a:avLst/>
+            </a:prstGeom>
+            <a:solidFill>
+              <a:srgbClr val="F1F5F9"/>
+            </a:solidFill>
+            <a:ln/>
+          </p:spPr>
+          <p:txBody>
+            <a:bodyPr/>
+            <a:lstStyle/>
+            <a:p>
+              <a:endParaRPr lang="es-ES"/>
+            </a:p>
+          </p:txBody>
+        </p:sp>
+        <p:sp>
+          <p:nvSpPr>
+            <p:cNvPr id="29" name="Text 17">
+              <a:extLst>
+                <a:ext uri="{FF2B5EF4-FFF2-40B4-BE49-F238E27FC236}">
+                  <a16:creationId xmlns:a16="http://schemas.microsoft.com/office/drawing/2014/main" id="{F61387B1-E720-DDC3-F1A2-4F01B3212C7F}"/>
+                </a:ext>
+              </a:extLst>
+            </p:cNvPr>
+            <p:cNvSpPr/>
+            <p:nvPr/>
+          </p:nvSpPr>
+          <p:spPr>
+            <a:xfrm>
+              <a:off x="6379412" y="2480379"/>
+              <a:ext cx="3336087" cy="301752"/>
+            </a:xfrm>
+            <a:prstGeom prst="rect">
+              <a:avLst/>
+            </a:prstGeom>
+            <a:noFill/>
+            <a:ln/>
+          </p:spPr>
+          <p:txBody>
+            <a:bodyPr wrap="square" lIns="0" tIns="0" rIns="0" bIns="0" rtlCol="0" anchor="ctr"/>
+            <a:lstStyle/>
+            <a:p>
+              <a:pPr marL="0" indent="0">
+                <a:buNone/>
+              </a:pPr>
+              <a:r>
+                <a:rPr lang="en-US" sz="1200" dirty="0">
+                  <a:solidFill>
+                    <a:srgbClr val="475569"/>
+                  </a:solidFill>
+                  <a:latin typeface="Calibri" pitchFamily="34" charset="0"/>
+                  <a:ea typeface="Calibri" pitchFamily="34" charset="-122"/>
+                  <a:cs typeface="Calibri" pitchFamily="34" charset="-120"/>
+                </a:rPr>
+                <a:t>Total interoperability &amp; interchangeability</a:t>
+              </a:r>
+            </a:p>
+            <a:p>
+              <a:pPr marL="0" indent="0">
+                <a:buNone/>
+              </a:pPr>
+              <a:endParaRPr lang="en-US" sz="1100" dirty="0"/>
+            </a:p>
+          </p:txBody>
+        </p:sp>
+      </p:grpSp>
+      <p:grpSp>
+        <p:nvGrpSpPr>
+          <p:cNvPr id="30" name="Group 29">
+            <a:extLst>
+              <a:ext uri="{FF2B5EF4-FFF2-40B4-BE49-F238E27FC236}">
+                <a16:creationId xmlns:a16="http://schemas.microsoft.com/office/drawing/2014/main" id="{EF27B7A5-B19C-54DB-E67D-4ADDBCCE95F8}"/>
+              </a:ext>
+            </a:extLst>
+          </p:cNvPr>
+          <p:cNvGrpSpPr/>
+          <p:nvPr/>
+        </p:nvGrpSpPr>
+        <p:grpSpPr>
+          <a:xfrm>
+            <a:off x="7029453" y="3629487"/>
+            <a:ext cx="1771651" cy="792584"/>
+            <a:chOff x="6172200" y="2466663"/>
+            <a:chExt cx="3566160" cy="315468"/>
+          </a:xfrm>
+        </p:grpSpPr>
+        <p:sp>
+          <p:nvSpPr>
+            <p:cNvPr id="31" name="Shape 16">
+              <a:extLst>
+                <a:ext uri="{FF2B5EF4-FFF2-40B4-BE49-F238E27FC236}">
+                  <a16:creationId xmlns:a16="http://schemas.microsoft.com/office/drawing/2014/main" id="{DA2434F2-F86F-3651-1A21-5B301185F9E1}"/>
+                </a:ext>
+              </a:extLst>
+            </p:cNvPr>
+            <p:cNvSpPr/>
+            <p:nvPr/>
+          </p:nvSpPr>
+          <p:spPr>
+            <a:xfrm>
+              <a:off x="6172200" y="2466663"/>
+              <a:ext cx="3566160" cy="301752"/>
+            </a:xfrm>
+            <a:prstGeom prst="rect">
+              <a:avLst/>
+            </a:prstGeom>
+            <a:solidFill>
+              <a:srgbClr val="F1F5F9"/>
+            </a:solidFill>
+            <a:ln/>
+          </p:spPr>
+          <p:txBody>
+            <a:bodyPr/>
+            <a:lstStyle/>
+            <a:p>
+              <a:endParaRPr lang="es-ES"/>
+            </a:p>
+          </p:txBody>
+        </p:sp>
+        <p:sp>
+          <p:nvSpPr>
+            <p:cNvPr id="32" name="Text 17">
+              <a:extLst>
+                <a:ext uri="{FF2B5EF4-FFF2-40B4-BE49-F238E27FC236}">
+                  <a16:creationId xmlns:a16="http://schemas.microsoft.com/office/drawing/2014/main" id="{0BCAB4CD-BD60-D31B-6A31-B2678E6E3272}"/>
+                </a:ext>
+              </a:extLst>
+            </p:cNvPr>
+            <p:cNvSpPr/>
+            <p:nvPr/>
+          </p:nvSpPr>
+          <p:spPr>
+            <a:xfrm>
+              <a:off x="6356552" y="2480379"/>
+              <a:ext cx="3358948" cy="301752"/>
+            </a:xfrm>
+            <a:prstGeom prst="rect">
+              <a:avLst/>
+            </a:prstGeom>
+            <a:noFill/>
+            <a:ln/>
+          </p:spPr>
+          <p:txBody>
+            <a:bodyPr wrap="square" lIns="0" tIns="0" rIns="0" bIns="0" rtlCol="0" anchor="ctr"/>
+            <a:lstStyle/>
+            <a:p>
+              <a:pPr marL="0" indent="0">
+                <a:buNone/>
+              </a:pPr>
+              <a:r>
+                <a:rPr lang="en-US" sz="1200" dirty="0">
+                  <a:solidFill>
+                    <a:srgbClr val="475569"/>
+                  </a:solidFill>
+                  <a:latin typeface="Calibri" pitchFamily="34" charset="0"/>
+                  <a:ea typeface="Calibri" pitchFamily="34" charset="-122"/>
+                  <a:cs typeface="Calibri" pitchFamily="34" charset="-120"/>
+                </a:rPr>
+                <a:t>Front/back fully decoupled. 100% </a:t>
+              </a:r>
+              <a:r>
+                <a:rPr lang="en-US" sz="1200" dirty="0" err="1">
+                  <a:solidFill>
+                    <a:srgbClr val="475569"/>
+                  </a:solidFill>
+                  <a:latin typeface="Calibri" pitchFamily="34" charset="0"/>
+                  <a:ea typeface="Calibri" pitchFamily="34" charset="-122"/>
+                  <a:cs typeface="Calibri" pitchFamily="34" charset="-120"/>
+                </a:rPr>
+                <a:t>APIfied</a:t>
+              </a:r>
+              <a:endParaRPr lang="en-US" sz="1200" dirty="0">
+                <a:solidFill>
+                  <a:srgbClr val="475569"/>
                 </a:solidFill>
                 <a:latin typeface="Calibri" pitchFamily="34" charset="0"/>
                 <a:ea typeface="Calibri" pitchFamily="34" charset="-122"/>
                 <a:cs typeface="Calibri" pitchFamily="34" charset="-120"/>
-              </a:rPr>
-              <a:t>1.  Real time log streaming</a:t>
-            </a:r>
-            <a:endParaRPr lang="en-US" sz="1500" dirty="0"/>
-          </a:p>
-        </p:txBody>
-      </p:sp>
-      <p:sp>
-        <p:nvSpPr>
-          <p:cNvPr id="7" name="Shape 5"/>
-          <p:cNvSpPr/>
-          <p:nvPr/>
-        </p:nvSpPr>
-        <p:spPr>
-          <a:xfrm>
-            <a:off x="1371600" y="2625634"/>
-            <a:ext cx="6400800" cy="438912"/>
-          </a:xfrm>
-          <a:prstGeom prst="rect">
-            <a:avLst/>
-          </a:prstGeom>
-          <a:solidFill>
-            <a:srgbClr val="1E293B"/>
-          </a:solidFill>
-          <a:ln/>
-        </p:spPr>
-        <p:txBody>
-          <a:bodyPr/>
-          <a:lstStyle/>
-          <a:p>
-            <a:endParaRPr lang="es-ES"/>
-          </a:p>
-        </p:txBody>
-      </p:sp>
-      <p:sp>
-        <p:nvSpPr>
-          <p:cNvPr id="8" name="Text 6"/>
-          <p:cNvSpPr/>
-          <p:nvPr/>
-        </p:nvSpPr>
-        <p:spPr>
-          <a:xfrm>
-            <a:off x="1554480" y="2625634"/>
-            <a:ext cx="6035040" cy="438912"/>
-          </a:xfrm>
-          <a:prstGeom prst="rect">
-            <a:avLst/>
-          </a:prstGeom>
-          <a:noFill/>
-          <a:ln/>
-        </p:spPr>
-        <p:txBody>
-          <a:bodyPr wrap="square" lIns="0" tIns="0" rIns="0" bIns="0" rtlCol="0" anchor="ctr"/>
-          <a:lstStyle/>
-          <a:p>
-            <a:pPr marL="0" indent="0">
-              <a:buNone/>
-            </a:pPr>
-            <a:r>
-              <a:rPr lang="en-US" sz="1500" dirty="0">
-                <a:solidFill>
-                  <a:srgbClr val="E2E8F0"/>
-                </a:solidFill>
-                <a:latin typeface="Calibri" pitchFamily="34" charset="0"/>
-                <a:ea typeface="Calibri" pitchFamily="34" charset="-122"/>
-                <a:cs typeface="Calibri" pitchFamily="34" charset="-120"/>
-              </a:rPr>
-              <a:t>2.  Namespaces &amp; pod metrics</a:t>
-            </a:r>
-            <a:endParaRPr lang="en-US" sz="1500" dirty="0"/>
-          </a:p>
-        </p:txBody>
-      </p:sp>
-      <p:sp>
-        <p:nvSpPr>
-          <p:cNvPr id="9" name="Shape 7"/>
-          <p:cNvSpPr/>
-          <p:nvPr/>
-        </p:nvSpPr>
-        <p:spPr>
-          <a:xfrm>
-            <a:off x="1371600" y="3722914"/>
-            <a:ext cx="6400800" cy="438912"/>
-          </a:xfrm>
-          <a:prstGeom prst="rect">
-            <a:avLst/>
-          </a:prstGeom>
-          <a:solidFill>
-            <a:srgbClr val="1E293B"/>
-          </a:solidFill>
-          <a:ln/>
-        </p:spPr>
-        <p:txBody>
-          <a:bodyPr/>
-          <a:lstStyle/>
-          <a:p>
-            <a:endParaRPr lang="es-ES"/>
-          </a:p>
-        </p:txBody>
-      </p:sp>
-      <p:sp>
-        <p:nvSpPr>
-          <p:cNvPr id="10" name="Text 8"/>
-          <p:cNvSpPr/>
-          <p:nvPr/>
-        </p:nvSpPr>
-        <p:spPr>
-          <a:xfrm>
-            <a:off x="1554480" y="3722914"/>
-            <a:ext cx="6035040" cy="438912"/>
-          </a:xfrm>
-          <a:prstGeom prst="rect">
-            <a:avLst/>
-          </a:prstGeom>
-          <a:noFill/>
-          <a:ln/>
-        </p:spPr>
-        <p:txBody>
-          <a:bodyPr wrap="square" lIns="0" tIns="0" rIns="0" bIns="0" rtlCol="0" anchor="ctr"/>
-          <a:lstStyle/>
-          <a:p>
-            <a:pPr marL="0" indent="0">
-              <a:buNone/>
-            </a:pPr>
-            <a:r>
-              <a:rPr lang="en-US" sz="1500" dirty="0">
-                <a:solidFill>
-                  <a:srgbClr val="E2E8F0"/>
-                </a:solidFill>
-                <a:latin typeface="Calibri" pitchFamily="34" charset="0"/>
-                <a:ea typeface="Calibri" pitchFamily="34" charset="-122"/>
-                <a:cs typeface="Calibri" pitchFamily="34" charset="-120"/>
-              </a:rPr>
-              <a:t>4. Magnify channel — cluster management</a:t>
-            </a:r>
-            <a:endParaRPr lang="en-US" sz="1500" dirty="0"/>
-          </a:p>
-        </p:txBody>
-      </p:sp>
-      <p:sp>
-        <p:nvSpPr>
-          <p:cNvPr id="11" name="Shape 9"/>
-          <p:cNvSpPr/>
-          <p:nvPr/>
-        </p:nvSpPr>
-        <p:spPr>
-          <a:xfrm>
-            <a:off x="1371600" y="4271554"/>
-            <a:ext cx="6400800" cy="438912"/>
-          </a:xfrm>
-          <a:prstGeom prst="rect">
-            <a:avLst/>
-          </a:prstGeom>
-          <a:solidFill>
-            <a:srgbClr val="1E293B"/>
-          </a:solidFill>
-          <a:ln/>
-        </p:spPr>
-        <p:txBody>
-          <a:bodyPr/>
-          <a:lstStyle/>
-          <a:p>
-            <a:endParaRPr lang="es-ES"/>
-          </a:p>
-        </p:txBody>
-      </p:sp>
-      <p:sp>
-        <p:nvSpPr>
-          <p:cNvPr id="12" name="Text 10"/>
-          <p:cNvSpPr/>
-          <p:nvPr/>
-        </p:nvSpPr>
-        <p:spPr>
-          <a:xfrm>
-            <a:off x="1554480" y="4271554"/>
-            <a:ext cx="6035040" cy="438912"/>
-          </a:xfrm>
-          <a:prstGeom prst="rect">
-            <a:avLst/>
-          </a:prstGeom>
-          <a:noFill/>
-          <a:ln/>
-        </p:spPr>
-        <p:txBody>
-          <a:bodyPr wrap="square" lIns="0" tIns="0" rIns="0" bIns="0" rtlCol="0" anchor="ctr"/>
-          <a:lstStyle/>
-          <a:p>
-            <a:pPr marL="0" indent="0">
-              <a:buNone/>
-            </a:pPr>
-            <a:r>
-              <a:rPr lang="en-US" sz="1500" dirty="0">
-                <a:solidFill>
-                  <a:srgbClr val="E2E8F0"/>
-                </a:solidFill>
-                <a:latin typeface="Calibri" pitchFamily="34" charset="0"/>
-                <a:ea typeface="Calibri" pitchFamily="34" charset="-122"/>
-                <a:cs typeface="Calibri" pitchFamily="34" charset="-120"/>
-              </a:rPr>
-              <a:t>5.  Pinocchio — ask your LLM about your cluster</a:t>
-            </a:r>
-            <a:endParaRPr lang="en-US" sz="1500" dirty="0"/>
-          </a:p>
-        </p:txBody>
-      </p:sp>
-      <p:sp>
-        <p:nvSpPr>
-          <p:cNvPr id="13" name="Shape 7">
+              </a:endParaRPr>
+            </a:p>
+          </p:txBody>
+        </p:sp>
+      </p:grpSp>
+      <p:sp>
+        <p:nvSpPr>
+          <p:cNvPr id="34" name="Oval 33">
             <a:extLst>
               <a:ext uri="{FF2B5EF4-FFF2-40B4-BE49-F238E27FC236}">
-                <a16:creationId xmlns:a16="http://schemas.microsoft.com/office/drawing/2014/main" id="{9F36C51D-57EA-5028-932C-1E0CC8A00790}"/>
+                <a16:creationId xmlns:a16="http://schemas.microsoft.com/office/drawing/2014/main" id="{7F01C2A6-4A0E-7004-7264-ADAE87E8F7FE}"/>
               </a:ext>
             </a:extLst>
           </p:cNvPr>
@@ -15889,31 +16666,54 @@
         </p:nvSpPr>
         <p:spPr>
           <a:xfrm>
-            <a:off x="1371600" y="3174274"/>
-            <a:ext cx="6400800" cy="438912"/>
-          </a:xfrm>
-          <a:prstGeom prst="rect">
+            <a:off x="2624111" y="2542565"/>
+            <a:ext cx="914400" cy="914400"/>
+          </a:xfrm>
+          <a:prstGeom prst="ellipse">
             <a:avLst/>
           </a:prstGeom>
           <a:solidFill>
-            <a:srgbClr val="1E293B"/>
+            <a:srgbClr val="FF0000">
+              <a:alpha val="26000"/>
+            </a:srgbClr>
           </a:solidFill>
-          <a:ln/>
-        </p:spPr>
-        <p:txBody>
-          <a:bodyPr/>
-          <a:lstStyle/>
-          <a:p>
+          <a:ln w="38100">
+            <a:solidFill>
+              <a:srgbClr val="7030A0"/>
+            </a:solidFill>
+          </a:ln>
+        </p:spPr>
+        <p:style>
+          <a:lnRef idx="2">
+            <a:schemeClr val="accent1">
+              <a:shade val="15000"/>
+            </a:schemeClr>
+          </a:lnRef>
+          <a:fillRef idx="1">
+            <a:schemeClr val="accent1"/>
+          </a:fillRef>
+          <a:effectRef idx="0">
+            <a:schemeClr val="accent1"/>
+          </a:effectRef>
+          <a:fontRef idx="minor">
+            <a:schemeClr val="lt1"/>
+          </a:fontRef>
+        </p:style>
+        <p:txBody>
+          <a:bodyPr rtlCol="0" anchor="ctr"/>
+          <a:lstStyle/>
+          <a:p>
+            <a:pPr algn="ctr"/>
             <a:endParaRPr lang="es-ES"/>
           </a:p>
         </p:txBody>
       </p:sp>
       <p:sp>
         <p:nvSpPr>
-          <p:cNvPr id="14" name="Text 8">
+          <p:cNvPr id="35" name="Oval 34">
             <a:extLst>
               <a:ext uri="{FF2B5EF4-FFF2-40B4-BE49-F238E27FC236}">
-                <a16:creationId xmlns:a16="http://schemas.microsoft.com/office/drawing/2014/main" id="{4544036D-6EFA-D449-8DD3-52C4A0218430}"/>
+                <a16:creationId xmlns:a16="http://schemas.microsoft.com/office/drawing/2014/main" id="{388303E6-1EB0-8C76-A56C-A593761ADF76}"/>
               </a:ext>
             </a:extLst>
           </p:cNvPr>
@@ -15922,49 +16722,54 @@
         </p:nvSpPr>
         <p:spPr>
           <a:xfrm>
-            <a:off x="1554480" y="3174274"/>
-            <a:ext cx="6035040" cy="438912"/>
-          </a:xfrm>
-          <a:prstGeom prst="rect">
-            <a:avLst/>
-          </a:prstGeom>
-          <a:noFill/>
-          <a:ln/>
-        </p:spPr>
-        <p:txBody>
-          <a:bodyPr wrap="square" lIns="0" tIns="0" rIns="0" bIns="0" rtlCol="0" anchor="ctr"/>
-          <a:lstStyle/>
-          <a:p>
-            <a:pPr marL="0" indent="0">
-              <a:buNone/>
-            </a:pPr>
-            <a:r>
-              <a:rPr lang="en-US" sz="1500" dirty="0">
-                <a:solidFill>
-                  <a:srgbClr val="E2E8F0"/>
-                </a:solidFill>
-                <a:latin typeface="Calibri" pitchFamily="34" charset="0"/>
-                <a:ea typeface="Calibri" pitchFamily="34" charset="-122"/>
-                <a:cs typeface="Calibri" pitchFamily="34" charset="-120"/>
-              </a:rPr>
-              <a:t>3.  Mor fun stuff with Fileman &amp; </a:t>
-            </a:r>
-            <a:r>
-              <a:rPr lang="en-US" sz="1500" dirty="0" err="1">
-                <a:solidFill>
-                  <a:srgbClr val="E2E8F0"/>
-                </a:solidFill>
-                <a:latin typeface="Calibri" pitchFamily="34" charset="0"/>
-                <a:ea typeface="Calibri" pitchFamily="34" charset="-122"/>
-                <a:cs typeface="Calibri" pitchFamily="34" charset="-120"/>
-              </a:rPr>
-              <a:t>Trivy</a:t>
-            </a:r>
-            <a:endParaRPr lang="en-US" sz="1500" dirty="0"/>
+            <a:off x="5168659" y="1307917"/>
+            <a:ext cx="914400" cy="914400"/>
+          </a:xfrm>
+          <a:prstGeom prst="ellipse">
+            <a:avLst/>
+          </a:prstGeom>
+          <a:solidFill>
+            <a:srgbClr val="FF0000">
+              <a:alpha val="26000"/>
+            </a:srgbClr>
+          </a:solidFill>
+          <a:ln w="38100">
+            <a:solidFill>
+              <a:srgbClr val="7030A0"/>
+            </a:solidFill>
+          </a:ln>
+        </p:spPr>
+        <p:style>
+          <a:lnRef idx="2">
+            <a:schemeClr val="accent1">
+              <a:shade val="15000"/>
+            </a:schemeClr>
+          </a:lnRef>
+          <a:fillRef idx="1">
+            <a:schemeClr val="accent1"/>
+          </a:fillRef>
+          <a:effectRef idx="0">
+            <a:schemeClr val="accent1"/>
+          </a:effectRef>
+          <a:fontRef idx="minor">
+            <a:schemeClr val="lt1"/>
+          </a:fontRef>
+        </p:style>
+        <p:txBody>
+          <a:bodyPr rtlCol="0" anchor="ctr"/>
+          <a:lstStyle/>
+          <a:p>
+            <a:pPr algn="ctr"/>
+            <a:endParaRPr lang="es-ES"/>
           </a:p>
         </p:txBody>
       </p:sp>
     </p:spTree>
+    <p:extLst>
+      <p:ext uri="{BB962C8B-B14F-4D97-AF65-F5344CB8AC3E}">
+        <p14:creationId xmlns:p14="http://schemas.microsoft.com/office/powerpoint/2010/main" val="939911887"/>
+      </p:ext>
+    </p:extLst>
   </p:cSld>
   <p:clrMapOvr>
     <a:masterClrMapping/>

</xml_diff>

<commit_message>
update version and presentation to 0.5.187
</commit_message>
<xml_diff>
--- a/docs/_media/kwirth_presentation.pptx
+++ b/docs/_media/kwirth_presentation.pptx
@@ -2160,7 +2160,7 @@
                 <a:ea typeface="Calibri" pitchFamily="34" charset="-122"/>
                 <a:cs typeface="Calibri" pitchFamily="34" charset="-120"/>
               </a:rPr>
-              <a:t>v 0.5.40</a:t>
+              <a:t>v0.5.40</a:t>
             </a:r>
             <a:endParaRPr lang="en-US" sz="1300" dirty="0"/>
           </a:p>
@@ -4087,7 +4087,7 @@
                 <a:ea typeface="Calibri" pitchFamily="34" charset="-122"/>
                 <a:cs typeface="Calibri" pitchFamily="34" charset="-120"/>
               </a:rPr>
-              <a:t>2.  Namespaces &amp; pod metrics</a:t>
+              <a:t>2.  Artifact metrics &amp; aggregation</a:t>
             </a:r>
             <a:endParaRPr lang="en-US" sz="1500" dirty="0"/>
           </a:p>
@@ -4297,7 +4297,7 @@
                 <a:ea typeface="Calibri" pitchFamily="34" charset="-122"/>
                 <a:cs typeface="Calibri" pitchFamily="34" charset="-120"/>
               </a:rPr>
-              <a:t>3.  Mor fun stuff with Fileman &amp; </a:t>
+              <a:t>3.  More fun stuff with Fileman &amp; </a:t>
             </a:r>
             <a:r>
               <a:rPr lang="en-US" sz="1500" dirty="0" err="1">
@@ -6429,7 +6429,7 @@
                 <a:ea typeface="Trebuchet MS" pitchFamily="34" charset="-122"/>
                 <a:cs typeface="Trebuchet MS" pitchFamily="34" charset="-120"/>
               </a:rPr>
-              <a:t>Arquitectura</a:t>
+              <a:t>Architecture</a:t>
             </a:r>
             <a:endParaRPr lang="en-US" sz="1600" dirty="0">
               <a:solidFill>
@@ -6661,7 +6661,7 @@
                 <a:ea typeface="Trebuchet MS" pitchFamily="34" charset="-122"/>
                 <a:cs typeface="Trebuchet MS" pitchFamily="34" charset="-120"/>
               </a:rPr>
-              <a:t>How to join the project</a:t>
+              <a:t>How to join the project?</a:t>
             </a:r>
             <a:endParaRPr lang="en-US" sz="3600" dirty="0"/>
           </a:p>
@@ -9279,7 +9279,7 @@
                 <a:ea typeface="Calibri" pitchFamily="34" charset="-122"/>
                 <a:cs typeface="Calibri" pitchFamily="34" charset="-120"/>
               </a:rPr>
-              <a:t>Observe &amp; manage Kubernetes can be… complex and hard.</a:t>
+              <a:t>Observe &amp; manage Kubernetes can be… complex, hard and expensive.</a:t>
             </a:r>
             <a:endParaRPr lang="en-US" sz="1800" dirty="0"/>
           </a:p>
@@ -9293,7 +9293,7 @@
         </p:nvSpPr>
         <p:spPr>
           <a:xfrm>
-            <a:off x="457200" y="1508760"/>
+            <a:off x="457200" y="1397725"/>
             <a:ext cx="3931920" cy="914400"/>
           </a:xfrm>
           <a:prstGeom prst="rect">
@@ -9327,7 +9327,7 @@
         </p:nvSpPr>
         <p:spPr>
           <a:xfrm>
-            <a:off x="457200" y="1508760"/>
+            <a:off x="457200" y="1397725"/>
             <a:ext cx="64008" cy="914400"/>
           </a:xfrm>
           <a:prstGeom prst="rect">
@@ -9354,7 +9354,7 @@
         </p:nvSpPr>
         <p:spPr>
           <a:xfrm>
-            <a:off x="594360" y="1600200"/>
+            <a:off x="594360" y="1489165"/>
             <a:ext cx="3657600" cy="320040"/>
           </a:xfrm>
           <a:prstGeom prst="rect">
@@ -9393,7 +9393,7 @@
         </p:nvSpPr>
         <p:spPr>
           <a:xfrm>
-            <a:off x="594360" y="1920240"/>
+            <a:off x="594360" y="1809205"/>
             <a:ext cx="3657600" cy="320040"/>
           </a:xfrm>
           <a:prstGeom prst="rect">
@@ -9432,7 +9432,7 @@
         </p:nvSpPr>
         <p:spPr>
           <a:xfrm>
-            <a:off x="457200" y="2606040"/>
+            <a:off x="457200" y="2495005"/>
             <a:ext cx="3931920" cy="914400"/>
           </a:xfrm>
           <a:prstGeom prst="rect">
@@ -9466,7 +9466,7 @@
         </p:nvSpPr>
         <p:spPr>
           <a:xfrm>
-            <a:off x="457200" y="2606040"/>
+            <a:off x="457200" y="2495005"/>
             <a:ext cx="64008" cy="914400"/>
           </a:xfrm>
           <a:prstGeom prst="rect">
@@ -9493,7 +9493,7 @@
         </p:nvSpPr>
         <p:spPr>
           <a:xfrm>
-            <a:off x="594360" y="2697480"/>
+            <a:off x="594360" y="2586445"/>
             <a:ext cx="3657600" cy="320040"/>
           </a:xfrm>
           <a:prstGeom prst="rect">
@@ -9532,7 +9532,7 @@
         </p:nvSpPr>
         <p:spPr>
           <a:xfrm>
-            <a:off x="594360" y="3017520"/>
+            <a:off x="594360" y="2906485"/>
             <a:ext cx="3657600" cy="320040"/>
           </a:xfrm>
           <a:prstGeom prst="rect">
@@ -9571,7 +9571,7 @@
         </p:nvSpPr>
         <p:spPr>
           <a:xfrm>
-            <a:off x="4663440" y="1508760"/>
+            <a:off x="4663440" y="1397725"/>
             <a:ext cx="3931920" cy="914400"/>
           </a:xfrm>
           <a:prstGeom prst="rect">
@@ -9605,7 +9605,7 @@
         </p:nvSpPr>
         <p:spPr>
           <a:xfrm>
-            <a:off x="4663440" y="1508760"/>
+            <a:off x="4663440" y="1397725"/>
             <a:ext cx="64008" cy="914400"/>
           </a:xfrm>
           <a:prstGeom prst="rect">
@@ -9632,7 +9632,7 @@
         </p:nvSpPr>
         <p:spPr>
           <a:xfrm>
-            <a:off x="4800600" y="1600200"/>
+            <a:off x="4800600" y="1489165"/>
             <a:ext cx="3657600" cy="320040"/>
           </a:xfrm>
           <a:prstGeom prst="rect">
@@ -9671,7 +9671,7 @@
         </p:nvSpPr>
         <p:spPr>
           <a:xfrm>
-            <a:off x="4800600" y="1920240"/>
+            <a:off x="4800600" y="1809205"/>
             <a:ext cx="3657600" cy="320040"/>
           </a:xfrm>
           <a:prstGeom prst="rect">
@@ -9710,7 +9710,7 @@
         </p:nvSpPr>
         <p:spPr>
           <a:xfrm>
-            <a:off x="4663440" y="2606040"/>
+            <a:off x="4663440" y="2495005"/>
             <a:ext cx="3931920" cy="914400"/>
           </a:xfrm>
           <a:prstGeom prst="rect">
@@ -9744,7 +9744,7 @@
         </p:nvSpPr>
         <p:spPr>
           <a:xfrm>
-            <a:off x="4663440" y="2606040"/>
+            <a:off x="4663440" y="2495005"/>
             <a:ext cx="64008" cy="914400"/>
           </a:xfrm>
           <a:prstGeom prst="rect">
@@ -9771,7 +9771,7 @@
         </p:nvSpPr>
         <p:spPr>
           <a:xfrm>
-            <a:off x="4800600" y="2697480"/>
+            <a:off x="4800600" y="2586445"/>
             <a:ext cx="3657600" cy="320040"/>
           </a:xfrm>
           <a:prstGeom prst="rect">
@@ -9810,7 +9810,7 @@
         </p:nvSpPr>
         <p:spPr>
           <a:xfrm>
-            <a:off x="4800600" y="3017520"/>
+            <a:off x="4800600" y="2906485"/>
             <a:ext cx="3657600" cy="320040"/>
           </a:xfrm>
           <a:prstGeom prst="rect">
@@ -9874,7 +9874,7 @@
                 <a:ea typeface="Calibri" pitchFamily="34" charset="-122"/>
                 <a:cs typeface="Calibri" pitchFamily="34" charset="-120"/>
               </a:rPr>
-              <a:t>¿What if you can find something simpler, that can be started with just a </a:t>
+              <a:t>What if you can find something simpler, that can be started with just a </a:t>
             </a:r>
             <a:r>
               <a:rPr lang="en-US" sz="1700" b="1" dirty="0" err="1">
@@ -9916,7 +9916,7 @@
         </p:nvSpPr>
         <p:spPr>
           <a:xfrm>
-            <a:off x="457200" y="3703320"/>
+            <a:off x="457200" y="3592285"/>
             <a:ext cx="3931920" cy="914400"/>
           </a:xfrm>
           <a:prstGeom prst="rect">
@@ -9956,7 +9956,7 @@
         </p:nvSpPr>
         <p:spPr>
           <a:xfrm>
-            <a:off x="457200" y="3703320"/>
+            <a:off x="457200" y="3592285"/>
             <a:ext cx="64008" cy="914400"/>
           </a:xfrm>
           <a:prstGeom prst="rect">
@@ -9989,7 +9989,7 @@
         </p:nvSpPr>
         <p:spPr>
           <a:xfrm>
-            <a:off x="594360" y="3794760"/>
+            <a:off x="594360" y="3683725"/>
             <a:ext cx="3657600" cy="320040"/>
           </a:xfrm>
           <a:prstGeom prst="rect">
@@ -10034,7 +10034,7 @@
         </p:nvSpPr>
         <p:spPr>
           <a:xfrm>
-            <a:off x="594360" y="4114800"/>
+            <a:off x="594360" y="4003765"/>
             <a:ext cx="3657600" cy="320040"/>
           </a:xfrm>
           <a:prstGeom prst="rect">
@@ -10079,7 +10079,7 @@
         </p:nvSpPr>
         <p:spPr>
           <a:xfrm>
-            <a:off x="4663440" y="3703320"/>
+            <a:off x="4663440" y="3592285"/>
             <a:ext cx="3931920" cy="914400"/>
           </a:xfrm>
           <a:prstGeom prst="rect">
@@ -10119,7 +10119,7 @@
         </p:nvSpPr>
         <p:spPr>
           <a:xfrm>
-            <a:off x="4663440" y="3703320"/>
+            <a:off x="4663440" y="3592285"/>
             <a:ext cx="64008" cy="914400"/>
           </a:xfrm>
           <a:prstGeom prst="rect">
@@ -10152,7 +10152,7 @@
         </p:nvSpPr>
         <p:spPr>
           <a:xfrm>
-            <a:off x="4800600" y="3794760"/>
+            <a:off x="4800600" y="3683725"/>
             <a:ext cx="3657600" cy="320040"/>
           </a:xfrm>
           <a:prstGeom prst="rect">
@@ -10197,7 +10197,7 @@
         </p:nvSpPr>
         <p:spPr>
           <a:xfrm>
-            <a:off x="4800600" y="4114800"/>
+            <a:off x="4800600" y="4003765"/>
             <a:ext cx="3657600" cy="320040"/>
           </a:xfrm>
           <a:prstGeom prst="rect">
@@ -10369,8 +10369,8 @@
         </p:nvSpPr>
         <p:spPr>
           <a:xfrm>
-            <a:off x="594360" y="1097280"/>
-            <a:ext cx="7955280" cy="1645920"/>
+            <a:off x="640080" y="1097280"/>
+            <a:ext cx="7909560" cy="1645920"/>
           </a:xfrm>
           <a:prstGeom prst="rect">
             <a:avLst/>
@@ -10470,7 +10470,7 @@
                 <a:ea typeface="Calibri" pitchFamily="34" charset="-122"/>
                 <a:cs typeface="Calibri" pitchFamily="34" charset="-120"/>
               </a:rPr>
-              <a:t>Logs, metrics, alerts, events, management — in real time.</a:t>
+              <a:t>Logs, metrics, alerts, events, AI, management… — in real time.</a:t>
             </a:r>
             <a:endParaRPr lang="en-US" sz="1800" dirty="0"/>
           </a:p>
@@ -11198,7 +11198,7 @@
                 <a:ea typeface="Calibri" pitchFamily="34" charset="-122"/>
                 <a:cs typeface="Calibri" pitchFamily="34" charset="-120"/>
               </a:rPr>
-              <a:t>Wirth's Law: "Software is getting slower more rapidly than hardware is becoming faster“</a:t>
+              <a:t>Wirth's Law: “Software is getting slower more rapidly than hardware is becoming faster”</a:t>
             </a:r>
           </a:p>
           <a:p>
@@ -11354,7 +11354,7 @@
                 <a:ea typeface="Calibri" pitchFamily="34" charset="-122"/>
                 <a:cs typeface="Calibri" pitchFamily="34" charset="-120"/>
               </a:rPr>
-              <a:t>The stylized "K" in the style of Roy Lichtenstein.</a:t>
+              <a:t>The stylized “K” in the style of Roy Lichtenstein.</a:t>
             </a:r>
           </a:p>
           <a:p>
@@ -11383,7 +11383,7 @@
                 <a:ea typeface="Calibri" pitchFamily="34" charset="-122"/>
                 <a:cs typeface="Calibri" pitchFamily="34" charset="-120"/>
               </a:rPr>
-              <a:t>Just as he used Ben-Day dots to create art from comics, Kwirth takes the cluster's "dots" (logs, metrics, events) and magnifies them into something clear and visual.</a:t>
+              <a:t>Just as he used Ben-Day dots to create art from comics, Kwirth takes the cluster’s “dots” (logs, metrics, events) and magnifies them into something clear and visual.</a:t>
             </a:r>
           </a:p>
           <a:p>
@@ -15376,7 +15376,7 @@
               <a:buNone/>
             </a:pPr>
             <a:r>
-              <a:rPr lang="en-US" sz="1100" dirty="0">
+              <a:rPr lang="nn-NO" sz="1100" dirty="0">
                 <a:solidFill>
                   <a:srgbClr val="0EA5E9"/>
                 </a:solidFill>
@@ -15384,7 +15384,7 @@
                 <a:ea typeface="Consolas" pitchFamily="34" charset="-122"/>
                 <a:cs typeface="Consolas" pitchFamily="34" charset="-120"/>
               </a:rPr>
-              <a:t>helm install kwirth kwirth/kwirth</a:t>
+              <a:t>npm i -g @kwirthmagnify/kwirth-external</a:t>
             </a:r>
             <a:endParaRPr lang="en-US" sz="1100" dirty="0"/>
           </a:p>
@@ -15423,7 +15423,7 @@
                 <a:ea typeface="Calibri" pitchFamily="34" charset="-122"/>
                 <a:cs typeface="Calibri" pitchFamily="34" charset="-120"/>
               </a:rPr>
-              <a:t>Modern and flexible chart for deploying via Helm</a:t>
+              <a:t>Deploy on top of your OS, next to client application (e.g., Backstage)</a:t>
             </a:r>
             <a:endParaRPr lang="en-US" sz="1200" dirty="0"/>
           </a:p>
@@ -16419,7 +16419,7 @@
                   <a:ea typeface="Calibri" pitchFamily="34" charset="-122"/>
                   <a:cs typeface="Calibri" pitchFamily="34" charset="-120"/>
                 </a:rPr>
-                <a:t>Same codebase, three different deployment options</a:t>
+                <a:t>Same codebase, four different deployment options</a:t>
               </a:r>
             </a:p>
             <a:p>
@@ -16640,14 +16640,17 @@
                 </a:rPr>
                 <a:t>APIfied</a:t>
               </a:r>
-              <a:endParaRPr lang="en-US" sz="1200" dirty="0">
-                <a:solidFill>
-                  <a:srgbClr val="475569"/>
-                </a:solidFill>
-                <a:latin typeface="Calibri" pitchFamily="34" charset="0"/>
-                <a:ea typeface="Calibri" pitchFamily="34" charset="-122"/>
-                <a:cs typeface="Calibri" pitchFamily="34" charset="-120"/>
-              </a:endParaRPr>
+              <a:r>
+                <a:rPr lang="en-US" sz="1200" dirty="0">
+                  <a:solidFill>
+                    <a:srgbClr val="475569"/>
+                  </a:solidFill>
+                  <a:latin typeface="Calibri" pitchFamily="34" charset="0"/>
+                  <a:ea typeface="Calibri" pitchFamily="34" charset="-122"/>
+                  <a:cs typeface="Calibri" pitchFamily="34" charset="-120"/>
+                </a:rPr>
+                <a:t>.</a:t>
+              </a:r>
             </a:p>
           </p:txBody>
         </p:sp>

</xml_diff>